<commit_message>
feat: narrated demo (edge-tts VO, 2:45, synced) + Brakepoint branding; deck/script match audio; checklist reduced to the single submit step
</commit_message>
<xml_diff>
--- a/deliverables/demo_deck.pptx
+++ b/deliverables/demo_deck.pptx
@@ -509,7 +509,7 @@
           <a:lstStyle/>
           <a:p>
             <a:r>
-              <a:t>What if the biggest hit in your screen is the worst drug target? This is a signed causal map of T-cell function — built with Claude Science.</a:t>
+              <a:t>What if the biggest hit in your screen is the worst drug target? This is Brakepoint — a signed causal map of T-cell function, built with Claude Science.</a:t>
             </a:r>
           </a:p>
         </p:txBody>
@@ -579,7 +579,7 @@
           <a:lstStyle/>
           <a:p>
             <a:r>
-              <a:t>We started from a simple question: in human T cells, which genes — when you knock them down — make the cell a better effector, and which just break it? The better-effector genes are the brakes: release them and you boost the immune response. But in a genome-scale screen, those brakes hide among twelve thousand knockdowns across two and a half million cells.</a:t>
+              <a:t>Our question: in human T cells, which knockdowns make the cell a better effector, and which just break it? The better-effector genes are the brakes — release them, and you boost immunity. But they hide among twelve thousand knockdowns, across two and a half million cells.</a:t>
             </a:r>
           </a:p>
         </p:txBody>
@@ -649,7 +649,7 @@
           <a:lstStyle/>
           <a:p>
             <a:r>
-              <a:t>Everything you're about to see was built with Claude Science, and every number carries its provenance. Each result is a versioned artifact — its exact code, environment, and the conversation that produced it. A background reviewer checks every claim against what actually ran; it caught a real statistical bug in our effect-size metric before it ever reached a figure. The heavy compute runs on an NVIDIA DGX Spark — the signed map over 2.6 million cells finishes in about forty seconds. [OVERLAY: live Claude Science provenance capture]</a:t>
+              <a:t>Everything here was built with Claude Science, and every number carries its provenance. Each result is a versioned artifact — its code, its environment, the conversation behind it. A background reviewer checks every claim against what actually ran; it caught a real statistical bug before it reached a figure. The heavy compute runs on a DGX Spark — the map over two-point-six million cells, in forty seconds. [OPTIONAL OVERLAY: live Claude Science provenance capture]</a:t>
             </a:r>
           </a:p>
         </p:txBody>
@@ -719,7 +719,7 @@
           <a:lstStyle/>
           <a:p>
             <a:r>
-              <a:t>The method has two axes. First, causal effect size — a power-equalized energy distance — tells you how much a knockdown changes the cell. But magnitude alone can't tell a drug target from essential machinery: both land far from control. So we add a second axis: a per-cell direction-of-effect score. Positive means the knockdown pushes cells toward the effector program — a brake. Negative means it pushes them away — required machinery.</a:t>
+              <a:t>The method has two axes. Effect size — an energy distance — tells you how much a knockdown changes the cell. But magnitude can't separate a drug target from essential machinery; both land far from control. So we add direction: a per-cell score. Positive, the knockdown pushes cells toward the effector program — a brake. Negative, it's required machinery.</a:t>
             </a:r>
           </a:p>
         </p:txBody>
@@ -789,7 +789,7 @@
           <a:lstStyle/>
           <a:p>
             <a:r>
-              <a:t>And the map validates itself. Completely unsupervised, the largest effects are the entire TCR-signalling module — ZAP70, the CD3 complex, LAT, PLCG1. The direction axis then flags fourteen of the top fifteen as machinery, not targets — and it agrees across both donors, every time. A map that gets the machinery right is one you can trust to point at the brakes.</a:t>
+              <a:t>And the map validates itself. Unsupervised, the largest effects are the entire T-cell-receptor module — ZAP70, the CD3 complex, LAT. The direction axis flags fourteen of the top fifteen as machinery, not targets — and both donors agree, every time. Get the machinery right, and you can trust the brakes.</a:t>
             </a:r>
           </a:p>
         </p:txBody>
@@ -859,7 +859,7 @@
           <a:lstStyle/>
           <a:p>
             <a:r>
-              <a:t>This is the map. Effect size across the bottom, direction up the side. Down in the teal — the largest, most consistent effects — is the machinery: knocking it down cripples the cell. The drug signal is the sparse quadrant up top, in amber: knockdowns that enhance effector function. That's where the real targets live — and where a magnitude-only ranking would never have looked. [OVERLAY: live Claude Science capture of the run producing this figure]</a:t>
+              <a:t>This is the map. Effect size across the bottom, direction up the side. In teal, the largest, most consistent effects — the machinery: knock it down, you cripple the cell. The drug signal is the sparse amber quadrant up top: knockdowns that enhance effector function. That's where the real targets live. [OPTIONAL OVERLAY: live Claude Science capture of the run behind this figure]</a:t>
             </a:r>
           </a:p>
         </p:txBody>
@@ -929,7 +929,7 @@
           <a:lstStyle/>
           <a:p>
             <a:r>
-              <a:t>In that quadrant the map recovers real drug-target biology. CD5 and DGKA — classic inhibitory brakes, consistent across donors, and already being drugged. Higher-magnitude candidates like the TGF-beta node SMAD3 are donor-split at two donors, so we present them honestly, as a prioritized shortlist for the full four-donor cohort. The method is validated; the leads are exactly that — leads.</a:t>
+              <a:t>There, the map recovers real drug-target biology. CD5 and DGKA — classic brakes, consistent across donors, already being drugged. Higher-magnitude candidates like the TGF-beta node SMAD3 are donor-split at two donors, so we flag them honestly — a shortlist for the full four-donor cohort. The method is validated; the leads are leads.</a:t>
             </a:r>
           </a:p>
         </p:txBody>
@@ -999,7 +999,7 @@
           <a:lstStyle/>
           <a:p>
             <a:r>
-              <a:t>It's fully open source — fixed seeds, one command to reproduce. And the whole map, from raw cells to this figure, was built with Claude Science.</a:t>
+              <a:t>Fully open source — fixed seeds, one command to reproduce. The whole map, from raw cells to this figure, built with Claude Science.</a:t>
             </a:r>
           </a:p>
         </p:txBody>

</xml_diff>

<commit_message>
fix(honesty): red-team corrections — '8 of 9 largest are TCR' (SMARCD3 #8); brake quadrant NOT enriched (Mann-Whitney p=0.56, brake_enrichment.py) reframed as honest hypothesis space; rebuild video/deck/landing/summary to match
</commit_message>
<xml_diff>
--- a/deliverables/demo_deck.pptx
+++ b/deliverables/demo_deck.pptx
@@ -789,7 +789,7 @@
           <a:lstStyle/>
           <a:p>
             <a:r>
-              <a:t>And the map validates itself. Unsupervised, the largest effects are the entire T-cell-receptor module — ZAP70, the CD3 complex, LAT. The direction axis flags fourteen of the top fifteen as machinery, not targets — and both donors agree, every time. Get the machinery right, and you can trust the brakes.</a:t>
+              <a:t>And the map validates itself. Unsupervised, eight of the nine largest effects are the T-cell-receptor module — ZAP70, the CD3 complex, LAT. The direction axis flags fourteen of the top fifteen as machinery, not targets — and both donors agree, every time. That machinery result is the load-bearing one.</a:t>
             </a:r>
           </a:p>
         </p:txBody>
@@ -859,7 +859,7 @@
           <a:lstStyle/>
           <a:p>
             <a:r>
-              <a:t>This is the map. Effect size across the bottom, direction up the side. In teal, the largest, most consistent effects — the machinery: knock it down, you cripple the cell. The drug signal is the sparse amber quadrant up top: knockdowns that enhance effector function. That's where the real targets live. [OPTIONAL OVERLAY: live Claude Science capture of the run behind this figure]</a:t>
+              <a:t>This is the map. Effect size across the bottom, direction up the side. In teal, the largest, most consistent effects — the machinery: knock it down, you cripple the cell. Up top, in amber, the sparse positive quadrant: knockdowns that enhance effector function — the therapeutic hypothesis space a magnitude-only ranking would never have looked at. [OPTIONAL OVERLAY: live Claude Science capture of the run behind this figure]</a:t>
             </a:r>
           </a:p>
         </p:txBody>
@@ -929,7 +929,7 @@
           <a:lstStyle/>
           <a:p>
             <a:r>
-              <a:t>There, the map recovers real drug-target biology. CD5 and DGKA — classic brakes, consistent across donors, already being drugged. Higher-magnitude candidates like the TGF-beta node SMAD3 are donor-split at two donors, so we flag them honestly — a shortlist for the full four-donor cohort. The method is validated; the leads are leads.</a:t>
+              <a:t>And we report that quadrant honestly. Known brakes like CD5 and DGKA do land there, donor-consistent — a consistency check. But at two donors it isn't yet enriched for known brakes, and its strongest raw hits include likely artifacts. So the positive side is a prioritized hypothesis space for the full cohort; the validated result is the machinery axis.</a:t>
             </a:r>
           </a:p>
         </p:txBody>

</xml_diff>

<commit_message>
docs: rebuild deck from target-focused video; sync demo script to Andrew VO; finding leads with the target shortlist
</commit_message>
<xml_diff>
--- a/deliverables/demo_deck.pptx
+++ b/deliverables/demo_deck.pptx
@@ -509,7 +509,7 @@
           <a:lstStyle/>
           <a:p>
             <a:r>
-              <a:t>What if the biggest hit in your screen is the worst drug target? This is Brakepoint — a signed causal map of T-cell function, built with Claude Science.</a:t>
+              <a:t>A T cell's brakes are its best drug targets. This is Brakepoint — druggable-brake discovery from a two-and-a-half-million-cell screen, built with Claude Science.</a:t>
             </a:r>
           </a:p>
         </p:txBody>
@@ -579,7 +579,7 @@
           <a:lstStyle/>
           <a:p>
             <a:r>
-              <a:t>Our question: in human T cells, which knockdowns make the cell a better effector, and which just break it? The better-effector genes are the brakes — release them, and you boost immunity. But they hide among twelve thousand knockdowns, across two and a half million cells.</a:t>
+              <a:t>The most powerful immunotherapies — checkpoint blockade, CAR-T — all work by releasing brakes on T cells. So we asked a simple question: across the entire genome, which druggable genes are those brakes? Which knockdowns make a human T cell a stronger effector?</a:t>
             </a:r>
           </a:p>
         </p:txBody>
@@ -649,7 +649,7 @@
           <a:lstStyle/>
           <a:p>
             <a:r>
-              <a:t>Everything here was built with Claude Science, and every number carries its provenance. Each result is a versioned artifact — its code, its environment, the conversation behind it. A background reviewer checks every claim against what actually ran; it caught a real statistical bug before it reached a figure. The heavy compute runs on a DGX Spark — the map over two-point-six million cells, in forty seconds. [OPTIONAL OVERLAY: live Claude Science provenance capture]</a:t>
+              <a:t>We started from a genome-scale CRISPR-interference screen — twelve thousand gene knockdowns, across two and a half million primary human CD4 T cells, from the Gladstone Institutes.</a:t>
             </a:r>
           </a:p>
         </p:txBody>
@@ -719,7 +719,7 @@
           <a:lstStyle/>
           <a:p>
             <a:r>
-              <a:t>The method has two axes. Effect size — an energy distance — tells you how much a knockdown changes the cell. But magnitude can't separate a drug target from essential machinery; both land far from control. So we add direction: a per-cell score. Positive, the knockdown pushes cells toward the effector program — a brake. Negative, it's required machinery.</a:t>
+              <a:t>Ranking by effect size alone points at the wrong genes: the biggest hits are the cell's own essential signaling machinery. So we added a direction-of-effect axis. Now the machinery drops to the bottom, and the drug-relevant brakes rise to the top. This map is our discovery engine.</a:t>
             </a:r>
           </a:p>
         </p:txBody>
@@ -789,7 +789,7 @@
           <a:lstStyle/>
           <a:p>
             <a:r>
-              <a:t>And the map validates itself. Unsupervised, eight of the nine largest effects are the T-cell-receptor module — ZAP70, the CD3 complex, LAT. The direction axis flags fourteen of the top fifteen as machinery, not targets — and both donors agree, every time. That machinery result is the load-bearing one.</a:t>
+              <a:t>From that map, a shortlist of five druggable brakes — each scored across seven axes of convergent evidence: causal effect, direction, donor consistency, druggability, human genetics, and clinical precedent.</a:t>
             </a:r>
           </a:p>
         </p:txBody>
@@ -859,7 +859,7 @@
           <a:lstStyle/>
           <a:p>
             <a:r>
-              <a:t>This is the map. Effect size across the bottom, direction up the side. In teal, the largest, most consistent effects — the machinery: knock it down, you cripple the cell. Up top, in amber, the sparse positive quadrant: knockdowns that enhance effector function — the therapeutic hypothesis space a magnitude-only ranking would never have looked at. [OPTIONAL OVERLAY: live Claude Science capture of the run behind this figure]</a:t>
+              <a:t>Our lead is CBLB — a brake that's already a drug. Two oral CBL-B inhibitors are in trials, losing it causes autoimmunity in people, and it sits squarely in our brake quadrant. CD5 and DGKA follow — both consistent across donors, both clinically tractable.</a:t>
             </a:r>
           </a:p>
         </p:txBody>
@@ -929,7 +929,7 @@
           <a:lstStyle/>
           <a:p>
             <a:r>
-              <a:t>And we report that quadrant honestly. Known brakes like CD5 and DGKA do land there, donor-consistent — a consistency check. But at two donors it isn't yet enriched for known brakes, and its strongest raw hits include likely artifacts. So the positive side is a prioritized hypothesis space for the full cohort; the validated result is the machinery axis.</a:t>
+              <a:t>And we report it honestly. With two donors, CD5 and DGKA hold up in both; CBLB and the higher-effect candidates are driven by one donor, and known brakes aren't yet enriched as a group. So this is a prioritized shortlist for the full cohort — not a finished target list.</a:t>
             </a:r>
           </a:p>
         </p:txBody>
@@ -999,7 +999,7 @@
           <a:lstStyle/>
           <a:p>
             <a:r>
-              <a:t>Fully open source — fixed seeds, one command to reproduce. The whole map, from raw cells to this figure, built with Claude Science.</a:t>
+              <a:t>Every target traces back to code — open source, one command to reproduce, built with Claude Science.</a:t>
             </a:r>
           </a:p>
         </p:txBody>
@@ -4007,7 +4007,7 @@
       <p:grpSpPr/>
       <p:pic>
         <p:nvPicPr>
-          <p:cNvPr id="2" name="Picture 1" descr="slide_0.png"/>
+          <p:cNvPr id="2" name="Picture 1" descr="s_0.png"/>
           <p:cNvPicPr>
             <a:picLocks noChangeAspect="1"/>
           </p:cNvPicPr>
@@ -4049,7 +4049,7 @@
       <p:grpSpPr/>
       <p:pic>
         <p:nvPicPr>
-          <p:cNvPr id="2" name="Picture 1" descr="slide_1.png"/>
+          <p:cNvPr id="2" name="Picture 1" descr="s_1.png"/>
           <p:cNvPicPr>
             <a:picLocks noChangeAspect="1"/>
           </p:cNvPicPr>
@@ -4091,7 +4091,7 @@
       <p:grpSpPr/>
       <p:pic>
         <p:nvPicPr>
-          <p:cNvPr id="2" name="Picture 1" descr="slide_2.png"/>
+          <p:cNvPr id="2" name="Picture 1" descr="s_2.png"/>
           <p:cNvPicPr>
             <a:picLocks noChangeAspect="1"/>
           </p:cNvPicPr>
@@ -4133,7 +4133,7 @@
       <p:grpSpPr/>
       <p:pic>
         <p:nvPicPr>
-          <p:cNvPr id="2" name="Picture 1" descr="slide_3.png"/>
+          <p:cNvPr id="2" name="Picture 1" descr="s_3.png"/>
           <p:cNvPicPr>
             <a:picLocks noChangeAspect="1"/>
           </p:cNvPicPr>
@@ -4175,7 +4175,7 @@
       <p:grpSpPr/>
       <p:pic>
         <p:nvPicPr>
-          <p:cNvPr id="2" name="Picture 1" descr="slide_4.png"/>
+          <p:cNvPr id="2" name="Picture 1" descr="s_4.png"/>
           <p:cNvPicPr>
             <a:picLocks noChangeAspect="1"/>
           </p:cNvPicPr>
@@ -4217,7 +4217,7 @@
       <p:grpSpPr/>
       <p:pic>
         <p:nvPicPr>
-          <p:cNvPr id="2" name="Picture 1" descr="slide_5.png"/>
+          <p:cNvPr id="2" name="Picture 1" descr="s_5.png"/>
           <p:cNvPicPr>
             <a:picLocks noChangeAspect="1"/>
           </p:cNvPicPr>
@@ -4259,7 +4259,7 @@
       <p:grpSpPr/>
       <p:pic>
         <p:nvPicPr>
-          <p:cNvPr id="2" name="Picture 1" descr="slide_6.png"/>
+          <p:cNvPr id="2" name="Picture 1" descr="s_6.png"/>
           <p:cNvPicPr>
             <a:picLocks noChangeAspect="1"/>
           </p:cNvPicPr>
@@ -4301,7 +4301,7 @@
       <p:grpSpPr/>
       <p:pic>
         <p:nvPicPr>
-          <p:cNvPr id="2" name="Picture 1" descr="slide_7.png"/>
+          <p:cNvPr id="2" name="Picture 1" descr="s_7.png"/>
           <p:cNvPicPr>
             <a:picLocks noChangeAspect="1"/>
           </p:cNvPicPr>

</xml_diff>

<commit_message>
fix(perfection pass, via Codex strict reviews): CBLB=investigational target not 'a drug'; CAR-T scoped out of brake-release; effector=transcriptional readout (validation pending); 'candidate targets for validation'; 'no significant enrichment'; donor-stratified not 'replicates'; TCR=wrong-direction-to-drug; single clean summary; trim IL2RB; fix figure label collisions; regen video+deck+one-pager
</commit_message>
<xml_diff>
--- a/deliverables/demo_deck.pptx
+++ b/deliverables/demo_deck.pptx
@@ -509,7 +509,7 @@
           <a:lstStyle/>
           <a:p>
             <a:r>
-              <a:t>A T cell's brakes are its best drug targets. This is Brakepoint — druggable-brake discovery from a two-and-a-half-million-cell screen, built with Claude Science.</a:t>
+              <a:t>A T cell's brakes are its best drug targets. This is Brakepoint — druggable-brake discovery from a 2.6-million-cell screen, built with Claude Science.</a:t>
             </a:r>
           </a:p>
         </p:txBody>
@@ -579,7 +579,7 @@
           <a:lstStyle/>
           <a:p>
             <a:r>
-              <a:t>The most powerful immunotherapies — checkpoint blockade, CAR-T — all work by releasing brakes on T cells. So we asked a simple question: across the entire genome, which druggable genes are those brakes? Which knockdowns make a human T cell a stronger effector?</a:t>
+              <a:t>Checkpoint blockade works by releasing the brakes on T cells; CAR-T engineers T cells to attack. Both point to the same prize. So we asked: across the genome, which druggable genes are the brakes — which knockdowns push a human T cell toward a stronger effector state?</a:t>
             </a:r>
           </a:p>
         </p:txBody>
@@ -649,7 +649,7 @@
           <a:lstStyle/>
           <a:p>
             <a:r>
-              <a:t>We started from a genome-scale CRISPR-interference screen — twelve thousand gene knockdowns, across two and a half million primary human CD4 T cells, from the Gladstone Institutes.</a:t>
+              <a:t>We started from a genome-scale CRISPR-interference screen — over twelve thousand gene knockdowns, across 2.6 million primary human CD4 T cells, from the Gladstone Institutes. Two donors, of an intended four.</a:t>
             </a:r>
           </a:p>
         </p:txBody>
@@ -719,7 +719,7 @@
           <a:lstStyle/>
           <a:p>
             <a:r>
-              <a:t>Ranking by effect size alone points at the wrong genes: the biggest hits are the cell's own essential signaling machinery. So we added a direction-of-effect axis. Now the machinery drops to the bottom, and the drug-relevant brakes rise to the top. This map is our discovery engine.</a:t>
+              <a:t>Ranking by effect size alone points at the wrong genes: the biggest hits are the cell's own essential signaling machinery. So we added a direction-of-effect axis — an 8-hour transcriptional readout. Now the machinery drops to the bottom, and the drug-relevant brakes rise to the top.</a:t>
             </a:r>
           </a:p>
         </p:txBody>
@@ -789,7 +789,7 @@
           <a:lstStyle/>
           <a:p>
             <a:r>
-              <a:t>From that map, a shortlist of five druggable brakes — each scored across seven axes of convergent evidence: causal effect, direction, donor consistency, druggability, human genetics, and clinical precedent.</a:t>
+              <a:t>From that map, five candidate brakes — CBLB, CD5, DGKA, SMAD3, and UBASH3A — each scored across seven axes of convergent evidence: causal effect, direction, donor consistency, viability, druggability, human genetics, and clinical precedent.</a:t>
             </a:r>
           </a:p>
         </p:txBody>
@@ -859,7 +859,7 @@
           <a:lstStyle/>
           <a:p>
             <a:r>
-              <a:t>Our lead is CBLB — a brake that's already a drug. Two oral CBL-B inhibitors are in trials, losing it causes autoimmunity in people, and it sits squarely in our brake quadrant. CD5 and DGKA follow — both consistent across donors, both clinically tractable.</a:t>
+              <a:t>Our lead is CBLB. Its inhibitors are already in early-phase trials, its human genetics are directionally consistent with a T-cell brake, and it sits squarely in our brake quadrant. CD5 and DGKA follow — consistent across both donors, with external tractability evidence.</a:t>
             </a:r>
           </a:p>
         </p:txBody>
@@ -929,7 +929,7 @@
           <a:lstStyle/>
           <a:p>
             <a:r>
-              <a:t>And we report it honestly. With two donors, CD5 and DGKA hold up in both; CBLB and the higher-effect candidates are driven by one donor, and known brakes aren't yet enriched as a group. So this is a prioritized shortlist for the full cohort — not a finished target list.</a:t>
+              <a:t>And we report it honestly. With just two donors, CD5 and DGKA hold up in both; CBLB and the higher-effect candidates are driven by one, and known brakes aren't yet enriched as a group. So this is a prioritized shortlist for the full four-donor cohort — a hypothesis to validate, not a finished target list.</a:t>
             </a:r>
           </a:p>
         </p:txBody>
@@ -999,7 +999,7 @@
           <a:lstStyle/>
           <a:p>
             <a:r>
-              <a:t>Every target traces back to code — open source, one command to reproduce, built with Claude Science.</a:t>
+              <a:t>Every candidate traces back to code — open source, one command to reproduce, built with Claude Science.</a:t>
             </a:r>
           </a:p>
         </p:txBody>

</xml_diff>

<commit_message>
chore: submission-length summary, video captions, refreshed deck + checklist
- summary.md: trim 281 -> 187 words (it had drifted over the 100-200 target)
- demo.vtt: synced WebVTT captions, shown by default on the landing video player
- demo_deck.pptx: rebuilt to 10 slides matching the current narration — drops the
  stale 'best drug targets' overclaim and the old 8-scene speaker notes
- SUBMISSION_CHECKLIST.md: refreshed to the current state (2:57 10-scene video,
  Andrew VO + captions, significance-wall + vs-traditional + interactive explorer,
  independently verified science)
</commit_message>
<xml_diff>
--- a/deliverables/demo_deck.pptx
+++ b/deliverables/demo_deck.pptx
@@ -13,6 +13,8 @@
     <p:sldId id="261" r:id="rId13"/>
     <p:sldId id="262" r:id="rId14"/>
     <p:sldId id="263" r:id="rId15"/>
+    <p:sldId id="264" r:id="rId16"/>
+    <p:sldId id="265" r:id="rId17"/>
   </p:sldIdLst>
   <p:sldSz cx="12191695" cy="6858000" type="screen4x3"/>
   <p:notesSz cx="6858000" cy="9144000"/>
@@ -509,7 +511,77 @@
           <a:lstStyle/>
           <a:p>
             <a:r>
-              <a:t>A T cell's brakes are its best drug targets. This is Brakepoint — druggable-brake discovery from a 2.6-million-cell screen, built with Claude Science.</a:t>
+              <a:t>Checkpoint immunotherapy works by releasing the brakes on a T cell. So we went looking for those brakes — genome-wide. This is Brakepoint, built with Claude Science.</a:t>
+            </a:r>
+          </a:p>
+        </p:txBody>
+      </p:sp>
+      <p:sp>
+        <p:nvSpPr>
+          <p:cNvPr id="4" name="Slide Number Placeholder 3"/>
+          <p:cNvSpPr>
+            <a:spLocks noGrp="1"/>
+          </p:cNvSpPr>
+          <p:nvPr>
+            <p:ph type="sldNum" idx="5" sz="quarter"/>
+          </p:nvPr>
+        </p:nvSpPr>
+        <p:spPr/>
+      </p:sp>
+    </p:spTree>
+  </p:cSld>
+  <p:clrMapOvr>
+    <a:masterClrMapping/>
+  </p:clrMapOvr>
+</p:notes>
+</file>
+
+<file path=ppt/notesSlides/notesSlide10.xml><?xml version="1.0" encoding="utf-8"?>
+<p:notes xmlns:a="http://schemas.openxmlformats.org/drawingml/2006/main" xmlns:p="http://schemas.openxmlformats.org/presentationml/2006/main" xmlns:r="http://schemas.openxmlformats.org/officeDocument/2006/relationships">
+  <p:cSld>
+    <p:spTree>
+      <p:nvGrpSpPr>
+        <p:cNvPr id="1" name=""/>
+        <p:cNvGrpSpPr/>
+        <p:nvPr/>
+      </p:nvGrpSpPr>
+      <p:grpSpPr>
+        <a:xfrm>
+          <a:off x="0" y="0"/>
+          <a:ext cx="0" cy="0"/>
+          <a:chOff x="0" y="0"/>
+          <a:chExt cx="0" cy="0"/>
+        </a:xfrm>
+      </p:grpSpPr>
+      <p:sp>
+        <p:nvSpPr>
+          <p:cNvPr id="2" name="Slide Image Placeholder 1"/>
+          <p:cNvSpPr>
+            <a:spLocks noGrp="1"/>
+          </p:cNvSpPr>
+          <p:nvPr>
+            <p:ph type="sldImg" idx="2"/>
+          </p:nvPr>
+        </p:nvSpPr>
+        <p:spPr/>
+      </p:sp>
+      <p:sp>
+        <p:nvSpPr>
+          <p:cNvPr id="3" name="Notes Placeholder 2"/>
+          <p:cNvSpPr>
+            <a:spLocks noGrp="1"/>
+          </p:cNvSpPr>
+          <p:nvPr>
+            <p:ph type="body" idx="3" sz="quarter"/>
+          </p:nvPr>
+        </p:nvSpPr>
+        <p:spPr/>
+        <p:txBody>
+          <a:bodyPr/>
+          <a:lstStyle/>
+          <a:p>
+            <a:r>
+              <a:t>Every number here traces back to versioned code — and to a self-check that caught a real bias in our effect-size code before it reached a figure. Open source; every figure regenerates with one command. This is Brakepoint, built with Claude Science.</a:t>
             </a:r>
           </a:p>
         </p:txBody>
@@ -579,7 +651,7 @@
           <a:lstStyle/>
           <a:p>
             <a:r>
-              <a:t>Checkpoint blockade works by releasing the brakes on T cells; CAR-T engineers T cells to attack. Both point to the same prize. So we asked: across the genome, which druggable genes are the brakes — which knockdowns push a human T cell toward a stronger effector state?</a:t>
+              <a:t>Those brakes matter beyond checkpoint therapy — they also throttle engineered CAR-T. So across the genome, which genes are the brakes — which knockdowns push a human T cell toward a stronger effector state?</a:t>
             </a:r>
           </a:p>
         </p:txBody>
@@ -649,7 +721,7 @@
           <a:lstStyle/>
           <a:p>
             <a:r>
-              <a:t>We started from a genome-scale CRISPR-interference screen — over twelve thousand gene knockdowns, across 2.6 million primary human CD4 T cells, from the Gladstone Institutes. Two donors, of an intended four.</a:t>
+              <a:t>We started from a genome-scale CRISPR-interference screen: over twelve thousand gene knockdowns, across 2.6 million primary human CD4 T cells, from the Gladstone Institutes. Two donors, out of an intended four.</a:t>
             </a:r>
           </a:p>
         </p:txBody>
@@ -719,7 +791,7 @@
           <a:lstStyle/>
           <a:p>
             <a:r>
-              <a:t>Ranking by effect size alone points at the wrong genes: the biggest hits are the cell's own essential signaling machinery. So we added a direction-of-effect axis — an 8-hour transcriptional readout. Now the machinery drops to the bottom, and the drug-relevant brakes rise to the top.</a:t>
+              <a:t>How do you find the brakes in twelve thousand knockdowns? The reflex is to rank by significance — but at two million cells that breaks down: over 97% of the tested knockdowns clear the bar. So we rank by causal effect size instead.</a:t>
             </a:r>
           </a:p>
         </p:txBody>
@@ -789,7 +861,7 @@
           <a:lstStyle/>
           <a:p>
             <a:r>
-              <a:t>From that map, five candidate brakes — CBLB, CD5, DGKA, SMAD3, and UBASH3A — each scored across seven axes of convergent evidence: causal effect, direction, donor consistency, viability, druggability, human genetics, and clinical precedent.</a:t>
+              <a:t>But effect size alone still points at the wrong genes — the biggest hits are the cell's own signaling machinery. So we add what a magnitude ranking leaves out: direction — toward the effector program, or away. Now the machinery falls away, and the candidate brakes rise into view.</a:t>
             </a:r>
           </a:p>
         </p:txBody>
@@ -859,7 +931,7 @@
           <a:lstStyle/>
           <a:p>
             <a:r>
-              <a:t>Our lead is CBLB. Its inhibitors are already in early-phase trials, its human genetics are directionally consistent with a T-cell brake, and it sits squarely in our brake quadrant. CD5 and DGKA follow — consistent across both donors, with external tractability evidence.</a:t>
+              <a:t>And that's the edge. Differential expression finds correlations — not what to drug. Genetics points to a locus, rarely a direction. We measure what a knockdown actually does, and which way it pushes — then weigh it against genetics and the clinic.</a:t>
             </a:r>
           </a:p>
         </p:txBody>
@@ -929,7 +1001,7 @@
           <a:lstStyle/>
           <a:p>
             <a:r>
-              <a:t>And we report it honestly. With just two donors, CD5 and DGKA hold up in both; CBLB and the higher-effect candidates are driven by one, and known brakes aren't yet enriched as a group. So this is a prioritized shortlist for the full four-donor cohort — a hypothesis to validate, not a finished target list.</a:t>
+              <a:t>From that map, five prior-informed candidates: CBLB, CD5, DGKA, SMAD3, and UBASH3A — each scored across seven lines of evidence, from causal effect and direction to human genetics and clinical precedent.</a:t>
             </a:r>
           </a:p>
         </p:txBody>
@@ -999,7 +1071,77 @@
           <a:lstStyle/>
           <a:p>
             <a:r>
-              <a:t>Every candidate traces back to code — open source, one command to reproduce, built with Claude Science.</a:t>
+              <a:t>Our lead is CBLB. It's a natural off-switch for T-cell activation, and inhibitors are already in early-phase trials. Its genetics point the same way, and it lands in our brake quadrant. CD5 and DGKA come next — and both hold up across donors.</a:t>
+            </a:r>
+          </a:p>
+        </p:txBody>
+      </p:sp>
+      <p:sp>
+        <p:nvSpPr>
+          <p:cNvPr id="4" name="Slide Number Placeholder 3"/>
+          <p:cNvSpPr>
+            <a:spLocks noGrp="1"/>
+          </p:cNvSpPr>
+          <p:nvPr>
+            <p:ph type="sldNum" idx="5" sz="quarter"/>
+          </p:nvPr>
+        </p:nvSpPr>
+        <p:spPr/>
+      </p:sp>
+    </p:spTree>
+  </p:cSld>
+  <p:clrMapOvr>
+    <a:masterClrMapping/>
+  </p:clrMapOvr>
+</p:notes>
+</file>
+
+<file path=ppt/notesSlides/notesSlide9.xml><?xml version="1.0" encoding="utf-8"?>
+<p:notes xmlns:a="http://schemas.openxmlformats.org/drawingml/2006/main" xmlns:p="http://schemas.openxmlformats.org/presentationml/2006/main" xmlns:r="http://schemas.openxmlformats.org/officeDocument/2006/relationships">
+  <p:cSld>
+    <p:spTree>
+      <p:nvGrpSpPr>
+        <p:cNvPr id="1" name=""/>
+        <p:cNvGrpSpPr/>
+        <p:nvPr/>
+      </p:nvGrpSpPr>
+      <p:grpSpPr>
+        <a:xfrm>
+          <a:off x="0" y="0"/>
+          <a:ext cx="0" cy="0"/>
+          <a:chOff x="0" y="0"/>
+          <a:chExt cx="0" cy="0"/>
+        </a:xfrm>
+      </p:grpSpPr>
+      <p:sp>
+        <p:nvSpPr>
+          <p:cNvPr id="2" name="Slide Image Placeholder 1"/>
+          <p:cNvSpPr>
+            <a:spLocks noGrp="1"/>
+          </p:cNvSpPr>
+          <p:nvPr>
+            <p:ph type="sldImg" idx="2"/>
+          </p:nvPr>
+        </p:nvSpPr>
+        <p:spPr/>
+      </p:sp>
+      <p:sp>
+        <p:nvSpPr>
+          <p:cNvPr id="3" name="Notes Placeholder 2"/>
+          <p:cNvSpPr>
+            <a:spLocks noGrp="1"/>
+          </p:cNvSpPr>
+          <p:nvPr>
+            <p:ph type="body" idx="3" sz="quarter"/>
+          </p:nvPr>
+        </p:nvSpPr>
+        <p:spPr/>
+        <p:txBody>
+          <a:bodyPr/>
+          <a:lstStyle/>
+          <a:p>
+            <a:r>
+              <a:t>And we're honest about what two donors can support. CD5 and DGKA hold up in both; the other three ride on one donor. As a group, known brakes aren't significantly enriched — so this is a ranked shortlist for the full cohort, a hypothesis to test, not a finished answer.</a:t>
             </a:r>
           </a:p>
         </p:txBody>
@@ -3998,6 +4140,14 @@
 <file path=ppt/slides/slide1.xml><?xml version="1.0" encoding="utf-8"?>
 <p:sld xmlns:a="http://schemas.openxmlformats.org/drawingml/2006/main" xmlns:p="http://schemas.openxmlformats.org/presentationml/2006/main" xmlns:r="http://schemas.openxmlformats.org/officeDocument/2006/relationships">
   <p:cSld>
+    <p:bg>
+      <p:bgPr>
+        <a:solidFill>
+          <a:srgbClr val="0A1211"/>
+        </a:solidFill>
+        <a:effectLst/>
+      </p:bgPr>
+    </p:bg>
     <p:spTree>
       <p:nvGrpSpPr>
         <p:cNvPr id="1" name=""/>
@@ -4005,30 +4155,272 @@
         <p:nvPr/>
       </p:nvGrpSpPr>
       <p:grpSpPr/>
-      <p:pic>
-        <p:nvPicPr>
-          <p:cNvPr id="2" name="Picture 1" descr="s_0.png"/>
-          <p:cNvPicPr>
-            <a:picLocks noChangeAspect="1"/>
-          </p:cNvPicPr>
+      <p:sp>
+        <p:nvSpPr>
+          <p:cNvPr id="2" name="TextBox 1"/>
+          <p:cNvSpPr txBox="1"/>
           <p:nvPr/>
-        </p:nvPicPr>
-        <p:blipFill>
-          <a:blip r:embed="rId2"/>
-          <a:stretch>
-            <a:fillRect/>
-          </a:stretch>
-        </p:blipFill>
+        </p:nvSpPr>
         <p:spPr>
           <a:xfrm>
-            <a:off x="0" y="0"/>
-            <a:ext cx="12191695" cy="6858000"/>
+            <a:off x="822960" y="914400"/>
+            <a:ext cx="10515600" cy="457200"/>
           </a:xfrm>
           <a:prstGeom prst="rect">
             <a:avLst/>
           </a:prstGeom>
+          <a:noFill/>
         </p:spPr>
-      </p:pic>
+        <p:txBody>
+          <a:bodyPr wrap="none">
+            <a:spAutoFit/>
+          </a:bodyPr>
+          <a:lstStyle/>
+          <a:p>
+            <a:r>
+              <a:rPr sz="1500" b="1">
+                <a:solidFill>
+                  <a:srgbClr val="2FD6BF"/>
+                </a:solidFill>
+                <a:latin typeface="Arial"/>
+              </a:rPr>
+              <a:t>BRAKEPOINT · BUILT WITH CLAUDE</a:t>
+            </a:r>
+          </a:p>
+        </p:txBody>
+      </p:sp>
+      <p:sp>
+        <p:nvSpPr>
+          <p:cNvPr id="3" name="TextBox 2"/>
+          <p:cNvSpPr txBox="1"/>
+          <p:nvPr/>
+        </p:nvSpPr>
+        <p:spPr>
+          <a:xfrm>
+            <a:off x="822960" y="2011680"/>
+            <a:ext cx="10515600" cy="2926080"/>
+          </a:xfrm>
+          <a:prstGeom prst="rect">
+            <a:avLst/>
+          </a:prstGeom>
+          <a:noFill/>
+        </p:spPr>
+        <p:txBody>
+          <a:bodyPr wrap="square">
+            <a:spAutoFit/>
+          </a:bodyPr>
+          <a:lstStyle/>
+          <a:p>
+            <a:r>
+              <a:rPr sz="4600" b="1">
+                <a:solidFill>
+                  <a:srgbClr val="FFFFFF"/>
+                </a:solidFill>
+                <a:latin typeface="Arial"/>
+              </a:rPr>
+              <a:t>The </a:t>
+            </a:r>
+            <a:r>
+              <a:rPr sz="4600" b="1">
+                <a:solidFill>
+                  <a:srgbClr val="F4B062"/>
+                </a:solidFill>
+                <a:latin typeface="Arial"/>
+              </a:rPr>
+              <a:t>brakes</a:t>
+            </a:r>
+            <a:r>
+              <a:rPr sz="4600" b="1">
+                <a:solidFill>
+                  <a:srgbClr val="FFFFFF"/>
+                </a:solidFill>
+                <a:latin typeface="Arial"/>
+              </a:rPr>
+              <a:t> on a T cell are its drug targets.</a:t>
+            </a:r>
+          </a:p>
+        </p:txBody>
+      </p:sp>
+      <p:sp>
+        <p:nvSpPr>
+          <p:cNvPr id="4" name="TextBox 3"/>
+          <p:cNvSpPr txBox="1"/>
+          <p:nvPr/>
+        </p:nvSpPr>
+        <p:spPr>
+          <a:xfrm>
+            <a:off x="822960" y="6126480"/>
+            <a:ext cx="10515600" cy="457200"/>
+          </a:xfrm>
+          <a:prstGeom prst="rect">
+            <a:avLst/>
+          </a:prstGeom>
+          <a:noFill/>
+        </p:spPr>
+        <p:txBody>
+          <a:bodyPr wrap="none">
+            <a:spAutoFit/>
+          </a:bodyPr>
+          <a:lstStyle/>
+          <a:p>
+            <a:r>
+              <a:rPr sz="1200">
+                <a:solidFill>
+                  <a:srgbClr val="8FA39D"/>
+                </a:solidFill>
+                <a:latin typeface="Arial"/>
+              </a:rPr>
+              <a:t>Brakepoint · Built with Claude Science</a:t>
+            </a:r>
+          </a:p>
+        </p:txBody>
+      </p:sp>
+    </p:spTree>
+  </p:cSld>
+  <p:clrMapOvr>
+    <a:masterClrMapping/>
+  </p:clrMapOvr>
+</p:sld>
+</file>
+
+<file path=ppt/slides/slide10.xml><?xml version="1.0" encoding="utf-8"?>
+<p:sld xmlns:a="http://schemas.openxmlformats.org/drawingml/2006/main" xmlns:p="http://schemas.openxmlformats.org/presentationml/2006/main" xmlns:r="http://schemas.openxmlformats.org/officeDocument/2006/relationships">
+  <p:cSld>
+    <p:bg>
+      <p:bgPr>
+        <a:solidFill>
+          <a:srgbClr val="0A1211"/>
+        </a:solidFill>
+        <a:effectLst/>
+      </p:bgPr>
+    </p:bg>
+    <p:spTree>
+      <p:nvGrpSpPr>
+        <p:cNvPr id="1" name=""/>
+        <p:cNvGrpSpPr/>
+        <p:nvPr/>
+      </p:nvGrpSpPr>
+      <p:grpSpPr/>
+      <p:sp>
+        <p:nvSpPr>
+          <p:cNvPr id="2" name="TextBox 1"/>
+          <p:cNvSpPr txBox="1"/>
+          <p:nvPr/>
+        </p:nvSpPr>
+        <p:spPr>
+          <a:xfrm>
+            <a:off x="822960" y="914400"/>
+            <a:ext cx="10515600" cy="457200"/>
+          </a:xfrm>
+          <a:prstGeom prst="rect">
+            <a:avLst/>
+          </a:prstGeom>
+          <a:noFill/>
+        </p:spPr>
+        <p:txBody>
+          <a:bodyPr wrap="none">
+            <a:spAutoFit/>
+          </a:bodyPr>
+          <a:lstStyle/>
+          <a:p>
+            <a:r>
+              <a:rPr sz="1500" b="1">
+                <a:solidFill>
+                  <a:srgbClr val="2FD6BF"/>
+                </a:solidFill>
+                <a:latin typeface="Arial"/>
+              </a:rPr>
+              <a:t>OPEN SOURCE · MIT</a:t>
+            </a:r>
+          </a:p>
+        </p:txBody>
+      </p:sp>
+      <p:sp>
+        <p:nvSpPr>
+          <p:cNvPr id="3" name="TextBox 2"/>
+          <p:cNvSpPr txBox="1"/>
+          <p:nvPr/>
+        </p:nvSpPr>
+        <p:spPr>
+          <a:xfrm>
+            <a:off x="822960" y="2011680"/>
+            <a:ext cx="10515600" cy="2926080"/>
+          </a:xfrm>
+          <a:prstGeom prst="rect">
+            <a:avLst/>
+          </a:prstGeom>
+          <a:noFill/>
+        </p:spPr>
+        <p:txBody>
+          <a:bodyPr wrap="square">
+            <a:spAutoFit/>
+          </a:bodyPr>
+          <a:lstStyle/>
+          <a:p>
+            <a:r>
+              <a:rPr sz="4600" b="1">
+                <a:solidFill>
+                  <a:srgbClr val="FFFFFF"/>
+                </a:solidFill>
+                <a:latin typeface="Arial"/>
+              </a:rPr>
+              <a:t>Every number traces back to </a:t>
+            </a:r>
+            <a:r>
+              <a:rPr sz="4600" b="1">
+                <a:solidFill>
+                  <a:srgbClr val="2FD6BF"/>
+                </a:solidFill>
+                <a:latin typeface="Arial"/>
+              </a:rPr>
+              <a:t>code</a:t>
+            </a:r>
+            <a:r>
+              <a:rPr sz="4600" b="1">
+                <a:solidFill>
+                  <a:srgbClr val="FFFFFF"/>
+                </a:solidFill>
+                <a:latin typeface="Arial"/>
+              </a:rPr>
+              <a:t>.</a:t>
+            </a:r>
+          </a:p>
+        </p:txBody>
+      </p:sp>
+      <p:sp>
+        <p:nvSpPr>
+          <p:cNvPr id="4" name="TextBox 3"/>
+          <p:cNvSpPr txBox="1"/>
+          <p:nvPr/>
+        </p:nvSpPr>
+        <p:spPr>
+          <a:xfrm>
+            <a:off x="822960" y="6126480"/>
+            <a:ext cx="10515600" cy="457200"/>
+          </a:xfrm>
+          <a:prstGeom prst="rect">
+            <a:avLst/>
+          </a:prstGeom>
+          <a:noFill/>
+        </p:spPr>
+        <p:txBody>
+          <a:bodyPr wrap="none">
+            <a:spAutoFit/>
+          </a:bodyPr>
+          <a:lstStyle/>
+          <a:p>
+            <a:r>
+              <a:rPr sz="1200">
+                <a:solidFill>
+                  <a:srgbClr val="8FA39D"/>
+                </a:solidFill>
+                <a:latin typeface="Arial"/>
+              </a:rPr>
+              <a:t>Brakepoint · Built with Claude Science</a:t>
+            </a:r>
+          </a:p>
+        </p:txBody>
+      </p:sp>
     </p:spTree>
   </p:cSld>
   <p:clrMapOvr>
@@ -4040,6 +4432,14 @@
 <file path=ppt/slides/slide2.xml><?xml version="1.0" encoding="utf-8"?>
 <p:sld xmlns:a="http://schemas.openxmlformats.org/drawingml/2006/main" xmlns:p="http://schemas.openxmlformats.org/presentationml/2006/main" xmlns:r="http://schemas.openxmlformats.org/officeDocument/2006/relationships">
   <p:cSld>
+    <p:bg>
+      <p:bgPr>
+        <a:solidFill>
+          <a:srgbClr val="0A1211"/>
+        </a:solidFill>
+        <a:effectLst/>
+      </p:bgPr>
+    </p:bg>
     <p:spTree>
       <p:nvGrpSpPr>
         <p:cNvPr id="1" name=""/>
@@ -4047,30 +4447,126 @@
         <p:nvPr/>
       </p:nvGrpSpPr>
       <p:grpSpPr/>
-      <p:pic>
-        <p:nvPicPr>
-          <p:cNvPr id="2" name="Picture 1" descr="s_1.png"/>
-          <p:cNvPicPr>
-            <a:picLocks noChangeAspect="1"/>
-          </p:cNvPicPr>
+      <p:sp>
+        <p:nvSpPr>
+          <p:cNvPr id="2" name="TextBox 1"/>
+          <p:cNvSpPr txBox="1"/>
           <p:nvPr/>
-        </p:nvPicPr>
-        <p:blipFill>
-          <a:blip r:embed="rId2"/>
-          <a:stretch>
-            <a:fillRect/>
-          </a:stretch>
-        </p:blipFill>
+        </p:nvSpPr>
         <p:spPr>
           <a:xfrm>
-            <a:off x="0" y="0"/>
-            <a:ext cx="12191695" cy="6858000"/>
+            <a:off x="822960" y="914400"/>
+            <a:ext cx="10515600" cy="457200"/>
           </a:xfrm>
           <a:prstGeom prst="rect">
             <a:avLst/>
           </a:prstGeom>
+          <a:noFill/>
         </p:spPr>
-      </p:pic>
+        <p:txBody>
+          <a:bodyPr wrap="none">
+            <a:spAutoFit/>
+          </a:bodyPr>
+          <a:lstStyle/>
+          <a:p>
+            <a:r>
+              <a:rPr sz="1500" b="1">
+                <a:solidFill>
+                  <a:srgbClr val="2FD6BF"/>
+                </a:solidFill>
+                <a:latin typeface="Arial"/>
+              </a:rPr>
+              <a:t>THE THESIS</a:t>
+            </a:r>
+          </a:p>
+        </p:txBody>
+      </p:sp>
+      <p:sp>
+        <p:nvSpPr>
+          <p:cNvPr id="3" name="TextBox 2"/>
+          <p:cNvSpPr txBox="1"/>
+          <p:nvPr/>
+        </p:nvSpPr>
+        <p:spPr>
+          <a:xfrm>
+            <a:off x="822960" y="2011680"/>
+            <a:ext cx="10515600" cy="2926080"/>
+          </a:xfrm>
+          <a:prstGeom prst="rect">
+            <a:avLst/>
+          </a:prstGeom>
+          <a:noFill/>
+        </p:spPr>
+        <p:txBody>
+          <a:bodyPr wrap="square">
+            <a:spAutoFit/>
+          </a:bodyPr>
+          <a:lstStyle/>
+          <a:p>
+            <a:r>
+              <a:rPr sz="4600" b="1">
+                <a:solidFill>
+                  <a:srgbClr val="FFFFFF"/>
+                </a:solidFill>
+                <a:latin typeface="Arial"/>
+              </a:rPr>
+              <a:t>Which knockdowns make a T cell a </a:t>
+            </a:r>
+            <a:r>
+              <a:rPr sz="4600" b="1">
+                <a:solidFill>
+                  <a:srgbClr val="F4B062"/>
+                </a:solidFill>
+                <a:latin typeface="Arial"/>
+              </a:rPr>
+              <a:t>stronger effector</a:t>
+            </a:r>
+            <a:r>
+              <a:rPr sz="4600" b="1">
+                <a:solidFill>
+                  <a:srgbClr val="FFFFFF"/>
+                </a:solidFill>
+                <a:latin typeface="Arial"/>
+              </a:rPr>
+              <a:t>?</a:t>
+            </a:r>
+          </a:p>
+        </p:txBody>
+      </p:sp>
+      <p:sp>
+        <p:nvSpPr>
+          <p:cNvPr id="4" name="TextBox 3"/>
+          <p:cNvSpPr txBox="1"/>
+          <p:nvPr/>
+        </p:nvSpPr>
+        <p:spPr>
+          <a:xfrm>
+            <a:off x="822960" y="6126480"/>
+            <a:ext cx="10515600" cy="457200"/>
+          </a:xfrm>
+          <a:prstGeom prst="rect">
+            <a:avLst/>
+          </a:prstGeom>
+          <a:noFill/>
+        </p:spPr>
+        <p:txBody>
+          <a:bodyPr wrap="none">
+            <a:spAutoFit/>
+          </a:bodyPr>
+          <a:lstStyle/>
+          <a:p>
+            <a:r>
+              <a:rPr sz="1200">
+                <a:solidFill>
+                  <a:srgbClr val="8FA39D"/>
+                </a:solidFill>
+                <a:latin typeface="Arial"/>
+              </a:rPr>
+              <a:t>Brakepoint · Built with Claude Science</a:t>
+            </a:r>
+          </a:p>
+        </p:txBody>
+      </p:sp>
     </p:spTree>
   </p:cSld>
   <p:clrMapOvr>
@@ -4082,6 +4578,14 @@
 <file path=ppt/slides/slide3.xml><?xml version="1.0" encoding="utf-8"?>
 <p:sld xmlns:a="http://schemas.openxmlformats.org/drawingml/2006/main" xmlns:p="http://schemas.openxmlformats.org/presentationml/2006/main" xmlns:r="http://schemas.openxmlformats.org/officeDocument/2006/relationships">
   <p:cSld>
+    <p:bg>
+      <p:bgPr>
+        <a:solidFill>
+          <a:srgbClr val="0A1211"/>
+        </a:solidFill>
+        <a:effectLst/>
+      </p:bgPr>
+    </p:bg>
     <p:spTree>
       <p:nvGrpSpPr>
         <p:cNvPr id="1" name=""/>
@@ -4089,30 +4593,126 @@
         <p:nvPr/>
       </p:nvGrpSpPr>
       <p:grpSpPr/>
-      <p:pic>
-        <p:nvPicPr>
-          <p:cNvPr id="2" name="Picture 1" descr="s_2.png"/>
-          <p:cNvPicPr>
-            <a:picLocks noChangeAspect="1"/>
-          </p:cNvPicPr>
+      <p:sp>
+        <p:nvSpPr>
+          <p:cNvPr id="2" name="TextBox 1"/>
+          <p:cNvSpPr txBox="1"/>
           <p:nvPr/>
-        </p:nvPicPr>
-        <p:blipFill>
-          <a:blip r:embed="rId2"/>
-          <a:stretch>
-            <a:fillRect/>
-          </a:stretch>
-        </p:blipFill>
+        </p:nvSpPr>
         <p:spPr>
           <a:xfrm>
-            <a:off x="0" y="0"/>
-            <a:ext cx="12191695" cy="6858000"/>
+            <a:off x="822960" y="914400"/>
+            <a:ext cx="10515600" cy="457200"/>
           </a:xfrm>
           <a:prstGeom prst="rect">
             <a:avLst/>
           </a:prstGeom>
+          <a:noFill/>
         </p:spPr>
-      </p:pic>
+        <p:txBody>
+          <a:bodyPr wrap="none">
+            <a:spAutoFit/>
+          </a:bodyPr>
+          <a:lstStyle/>
+          <a:p>
+            <a:r>
+              <a:rPr sz="1500" b="1">
+                <a:solidFill>
+                  <a:srgbClr val="2FD6BF"/>
+                </a:solidFill>
+                <a:latin typeface="Arial"/>
+              </a:rPr>
+              <a:t>THE SCREEN</a:t>
+            </a:r>
+          </a:p>
+        </p:txBody>
+      </p:sp>
+      <p:sp>
+        <p:nvSpPr>
+          <p:cNvPr id="3" name="TextBox 2"/>
+          <p:cNvSpPr txBox="1"/>
+          <p:nvPr/>
+        </p:nvSpPr>
+        <p:spPr>
+          <a:xfrm>
+            <a:off x="822960" y="2011680"/>
+            <a:ext cx="10515600" cy="2926080"/>
+          </a:xfrm>
+          <a:prstGeom prst="rect">
+            <a:avLst/>
+          </a:prstGeom>
+          <a:noFill/>
+        </p:spPr>
+        <p:txBody>
+          <a:bodyPr wrap="square">
+            <a:spAutoFit/>
+          </a:bodyPr>
+          <a:lstStyle/>
+          <a:p>
+            <a:r>
+              <a:rPr sz="4600" b="1">
+                <a:solidFill>
+                  <a:srgbClr val="FFFFFF"/>
+                </a:solidFill>
+                <a:latin typeface="Arial"/>
+              </a:rPr>
+              <a:t>2.6M CD4</a:t>
+            </a:r>
+            <a:r>
+              <a:rPr sz="4600" b="1">
+                <a:solidFill>
+                  <a:srgbClr val="2FD6BF"/>
+                </a:solidFill>
+                <a:latin typeface="Arial"/>
+              </a:rPr>
+              <a:t>+</a:t>
+            </a:r>
+            <a:r>
+              <a:rPr sz="4600" b="1">
+                <a:solidFill>
+                  <a:srgbClr val="FFFFFF"/>
+                </a:solidFill>
+                <a:latin typeface="Arial"/>
+              </a:rPr>
+              <a:t> T cells · 12,449 CRISPRi knockdowns.</a:t>
+            </a:r>
+          </a:p>
+        </p:txBody>
+      </p:sp>
+      <p:sp>
+        <p:nvSpPr>
+          <p:cNvPr id="4" name="TextBox 3"/>
+          <p:cNvSpPr txBox="1"/>
+          <p:nvPr/>
+        </p:nvSpPr>
+        <p:spPr>
+          <a:xfrm>
+            <a:off x="822960" y="6126480"/>
+            <a:ext cx="10515600" cy="457200"/>
+          </a:xfrm>
+          <a:prstGeom prst="rect">
+            <a:avLst/>
+          </a:prstGeom>
+          <a:noFill/>
+        </p:spPr>
+        <p:txBody>
+          <a:bodyPr wrap="none">
+            <a:spAutoFit/>
+          </a:bodyPr>
+          <a:lstStyle/>
+          <a:p>
+            <a:r>
+              <a:rPr sz="1200">
+                <a:solidFill>
+                  <a:srgbClr val="8FA39D"/>
+                </a:solidFill>
+                <a:latin typeface="Arial"/>
+              </a:rPr>
+              <a:t>Brakepoint · Built with Claude Science</a:t>
+            </a:r>
+          </a:p>
+        </p:txBody>
+      </p:sp>
     </p:spTree>
   </p:cSld>
   <p:clrMapOvr>
@@ -4124,6 +4724,14 @@
 <file path=ppt/slides/slide4.xml><?xml version="1.0" encoding="utf-8"?>
 <p:sld xmlns:a="http://schemas.openxmlformats.org/drawingml/2006/main" xmlns:p="http://schemas.openxmlformats.org/presentationml/2006/main" xmlns:r="http://schemas.openxmlformats.org/officeDocument/2006/relationships">
   <p:cSld>
+    <p:bg>
+      <p:bgPr>
+        <a:solidFill>
+          <a:srgbClr val="0A1211"/>
+        </a:solidFill>
+        <a:effectLst/>
+      </p:bgPr>
+    </p:bg>
     <p:spTree>
       <p:nvGrpSpPr>
         <p:cNvPr id="1" name=""/>
@@ -4131,30 +4739,126 @@
         <p:nvPr/>
       </p:nvGrpSpPr>
       <p:grpSpPr/>
-      <p:pic>
-        <p:nvPicPr>
-          <p:cNvPr id="2" name="Picture 1" descr="s_3.png"/>
-          <p:cNvPicPr>
-            <a:picLocks noChangeAspect="1"/>
-          </p:cNvPicPr>
+      <p:sp>
+        <p:nvSpPr>
+          <p:cNvPr id="2" name="TextBox 1"/>
+          <p:cNvSpPr txBox="1"/>
           <p:nvPr/>
-        </p:nvPicPr>
-        <p:blipFill>
-          <a:blip r:embed="rId2"/>
-          <a:stretch>
-            <a:fillRect/>
-          </a:stretch>
-        </p:blipFill>
+        </p:nvSpPr>
         <p:spPr>
           <a:xfrm>
-            <a:off x="0" y="0"/>
-            <a:ext cx="12191695" cy="6858000"/>
+            <a:off x="822960" y="914400"/>
+            <a:ext cx="10515600" cy="457200"/>
           </a:xfrm>
           <a:prstGeom prst="rect">
             <a:avLst/>
           </a:prstGeom>
+          <a:noFill/>
         </p:spPr>
-      </p:pic>
+        <p:txBody>
+          <a:bodyPr wrap="none">
+            <a:spAutoFit/>
+          </a:bodyPr>
+          <a:lstStyle/>
+          <a:p>
+            <a:r>
+              <a:rPr sz="1500" b="1">
+                <a:solidFill>
+                  <a:srgbClr val="2FD6BF"/>
+                </a:solidFill>
+                <a:latin typeface="Arial"/>
+              </a:rPr>
+              <a:t>THE TRAP · SIGNIFICANCE</a:t>
+            </a:r>
+          </a:p>
+        </p:txBody>
+      </p:sp>
+      <p:sp>
+        <p:nvSpPr>
+          <p:cNvPr id="3" name="TextBox 2"/>
+          <p:cNvSpPr txBox="1"/>
+          <p:nvPr/>
+        </p:nvSpPr>
+        <p:spPr>
+          <a:xfrm>
+            <a:off x="822960" y="2011680"/>
+            <a:ext cx="10515600" cy="2926080"/>
+          </a:xfrm>
+          <a:prstGeom prst="rect">
+            <a:avLst/>
+          </a:prstGeom>
+          <a:noFill/>
+        </p:spPr>
+        <p:txBody>
+          <a:bodyPr wrap="square">
+            <a:spAutoFit/>
+          </a:bodyPr>
+          <a:lstStyle/>
+          <a:p>
+            <a:r>
+              <a:rPr sz="4600" b="1">
+                <a:solidFill>
+                  <a:srgbClr val="FFFFFF"/>
+                </a:solidFill>
+                <a:latin typeface="Arial"/>
+              </a:rPr>
+              <a:t>Significance can't rank a </a:t>
+            </a:r>
+            <a:r>
+              <a:rPr sz="4600" b="1">
+                <a:solidFill>
+                  <a:srgbClr val="2FD6BF"/>
+                </a:solidFill>
+                <a:latin typeface="Arial"/>
+              </a:rPr>
+              <a:t>million-cell screen</a:t>
+            </a:r>
+            <a:r>
+              <a:rPr sz="4600" b="1">
+                <a:solidFill>
+                  <a:srgbClr val="FFFFFF"/>
+                </a:solidFill>
+                <a:latin typeface="Arial"/>
+              </a:rPr>
+              <a:t>.</a:t>
+            </a:r>
+          </a:p>
+        </p:txBody>
+      </p:sp>
+      <p:sp>
+        <p:nvSpPr>
+          <p:cNvPr id="4" name="TextBox 3"/>
+          <p:cNvSpPr txBox="1"/>
+          <p:nvPr/>
+        </p:nvSpPr>
+        <p:spPr>
+          <a:xfrm>
+            <a:off x="822960" y="6126480"/>
+            <a:ext cx="10515600" cy="457200"/>
+          </a:xfrm>
+          <a:prstGeom prst="rect">
+            <a:avLst/>
+          </a:prstGeom>
+          <a:noFill/>
+        </p:spPr>
+        <p:txBody>
+          <a:bodyPr wrap="none">
+            <a:spAutoFit/>
+          </a:bodyPr>
+          <a:lstStyle/>
+          <a:p>
+            <a:r>
+              <a:rPr sz="1200">
+                <a:solidFill>
+                  <a:srgbClr val="8FA39D"/>
+                </a:solidFill>
+                <a:latin typeface="Arial"/>
+              </a:rPr>
+              <a:t>Brakepoint · Built with Claude Science</a:t>
+            </a:r>
+          </a:p>
+        </p:txBody>
+      </p:sp>
     </p:spTree>
   </p:cSld>
   <p:clrMapOvr>
@@ -4166,6 +4870,14 @@
 <file path=ppt/slides/slide5.xml><?xml version="1.0" encoding="utf-8"?>
 <p:sld xmlns:a="http://schemas.openxmlformats.org/drawingml/2006/main" xmlns:p="http://schemas.openxmlformats.org/presentationml/2006/main" xmlns:r="http://schemas.openxmlformats.org/officeDocument/2006/relationships">
   <p:cSld>
+    <p:bg>
+      <p:bgPr>
+        <a:solidFill>
+          <a:srgbClr val="0A1211"/>
+        </a:solidFill>
+        <a:effectLst/>
+      </p:bgPr>
+    </p:bg>
     <p:spTree>
       <p:nvGrpSpPr>
         <p:cNvPr id="1" name=""/>
@@ -4173,30 +4885,126 @@
         <p:nvPr/>
       </p:nvGrpSpPr>
       <p:grpSpPr/>
-      <p:pic>
-        <p:nvPicPr>
-          <p:cNvPr id="2" name="Picture 1" descr="s_4.png"/>
-          <p:cNvPicPr>
-            <a:picLocks noChangeAspect="1"/>
-          </p:cNvPicPr>
+      <p:sp>
+        <p:nvSpPr>
+          <p:cNvPr id="2" name="TextBox 1"/>
+          <p:cNvSpPr txBox="1"/>
           <p:nvPr/>
-        </p:nvPicPr>
-        <p:blipFill>
-          <a:blip r:embed="rId2"/>
-          <a:stretch>
-            <a:fillRect/>
-          </a:stretch>
-        </p:blipFill>
+        </p:nvSpPr>
         <p:spPr>
           <a:xfrm>
-            <a:off x="0" y="0"/>
-            <a:ext cx="12191695" cy="6858000"/>
+            <a:off x="822960" y="914400"/>
+            <a:ext cx="10515600" cy="457200"/>
           </a:xfrm>
           <a:prstGeom prst="rect">
             <a:avLst/>
           </a:prstGeom>
+          <a:noFill/>
         </p:spPr>
-      </p:pic>
+        <p:txBody>
+          <a:bodyPr wrap="none">
+            <a:spAutoFit/>
+          </a:bodyPr>
+          <a:lstStyle/>
+          <a:p>
+            <a:r>
+              <a:rPr sz="1500" b="1">
+                <a:solidFill>
+                  <a:srgbClr val="2FD6BF"/>
+                </a:solidFill>
+                <a:latin typeface="Arial"/>
+              </a:rPr>
+              <a:t>THE ENGINE · SIGNED CAUSAL MAP</a:t>
+            </a:r>
+          </a:p>
+        </p:txBody>
+      </p:sp>
+      <p:sp>
+        <p:nvSpPr>
+          <p:cNvPr id="3" name="TextBox 2"/>
+          <p:cNvSpPr txBox="1"/>
+          <p:nvPr/>
+        </p:nvSpPr>
+        <p:spPr>
+          <a:xfrm>
+            <a:off x="822960" y="2011680"/>
+            <a:ext cx="10515600" cy="2926080"/>
+          </a:xfrm>
+          <a:prstGeom prst="rect">
+            <a:avLst/>
+          </a:prstGeom>
+          <a:noFill/>
+        </p:spPr>
+        <p:txBody>
+          <a:bodyPr wrap="square">
+            <a:spAutoFit/>
+          </a:bodyPr>
+          <a:lstStyle/>
+          <a:p>
+            <a:r>
+              <a:rPr sz="4600" b="1">
+                <a:solidFill>
+                  <a:srgbClr val="FFFFFF"/>
+                </a:solidFill>
+                <a:latin typeface="Arial"/>
+              </a:rPr>
+              <a:t>Rank by effect size, then add the </a:t>
+            </a:r>
+            <a:r>
+              <a:rPr sz="4600" b="1">
+                <a:solidFill>
+                  <a:srgbClr val="F4B062"/>
+                </a:solidFill>
+                <a:latin typeface="Arial"/>
+              </a:rPr>
+              <a:t>sign</a:t>
+            </a:r>
+            <a:r>
+              <a:rPr sz="4600" b="1">
+                <a:solidFill>
+                  <a:srgbClr val="FFFFFF"/>
+                </a:solidFill>
+                <a:latin typeface="Arial"/>
+              </a:rPr>
+              <a:t>.</a:t>
+            </a:r>
+          </a:p>
+        </p:txBody>
+      </p:sp>
+      <p:sp>
+        <p:nvSpPr>
+          <p:cNvPr id="4" name="TextBox 3"/>
+          <p:cNvSpPr txBox="1"/>
+          <p:nvPr/>
+        </p:nvSpPr>
+        <p:spPr>
+          <a:xfrm>
+            <a:off x="822960" y="6126480"/>
+            <a:ext cx="10515600" cy="457200"/>
+          </a:xfrm>
+          <a:prstGeom prst="rect">
+            <a:avLst/>
+          </a:prstGeom>
+          <a:noFill/>
+        </p:spPr>
+        <p:txBody>
+          <a:bodyPr wrap="none">
+            <a:spAutoFit/>
+          </a:bodyPr>
+          <a:lstStyle/>
+          <a:p>
+            <a:r>
+              <a:rPr sz="1200">
+                <a:solidFill>
+                  <a:srgbClr val="8FA39D"/>
+                </a:solidFill>
+                <a:latin typeface="Arial"/>
+              </a:rPr>
+              <a:t>Brakepoint · Built with Claude Science</a:t>
+            </a:r>
+          </a:p>
+        </p:txBody>
+      </p:sp>
     </p:spTree>
   </p:cSld>
   <p:clrMapOvr>
@@ -4208,6 +5016,14 @@
 <file path=ppt/slides/slide6.xml><?xml version="1.0" encoding="utf-8"?>
 <p:sld xmlns:a="http://schemas.openxmlformats.org/drawingml/2006/main" xmlns:p="http://schemas.openxmlformats.org/presentationml/2006/main" xmlns:r="http://schemas.openxmlformats.org/officeDocument/2006/relationships">
   <p:cSld>
+    <p:bg>
+      <p:bgPr>
+        <a:solidFill>
+          <a:srgbClr val="0A1211"/>
+        </a:solidFill>
+        <a:effectLst/>
+      </p:bgPr>
+    </p:bg>
     <p:spTree>
       <p:nvGrpSpPr>
         <p:cNvPr id="1" name=""/>
@@ -4215,30 +5031,117 @@
         <p:nvPr/>
       </p:nvGrpSpPr>
       <p:grpSpPr/>
-      <p:pic>
-        <p:nvPicPr>
-          <p:cNvPr id="2" name="Picture 1" descr="s_5.png"/>
-          <p:cNvPicPr>
-            <a:picLocks noChangeAspect="1"/>
-          </p:cNvPicPr>
+      <p:sp>
+        <p:nvSpPr>
+          <p:cNvPr id="2" name="TextBox 1"/>
+          <p:cNvSpPr txBox="1"/>
           <p:nvPr/>
-        </p:nvPicPr>
-        <p:blipFill>
-          <a:blip r:embed="rId2"/>
-          <a:stretch>
-            <a:fillRect/>
-          </a:stretch>
-        </p:blipFill>
+        </p:nvSpPr>
         <p:spPr>
           <a:xfrm>
-            <a:off x="0" y="0"/>
-            <a:ext cx="12191695" cy="6858000"/>
+            <a:off x="822960" y="914400"/>
+            <a:ext cx="10515600" cy="457200"/>
           </a:xfrm>
           <a:prstGeom prst="rect">
             <a:avLst/>
           </a:prstGeom>
+          <a:noFill/>
         </p:spPr>
-      </p:pic>
+        <p:txBody>
+          <a:bodyPr wrap="none">
+            <a:spAutoFit/>
+          </a:bodyPr>
+          <a:lstStyle/>
+          <a:p>
+            <a:r>
+              <a:rPr sz="1500" b="1">
+                <a:solidFill>
+                  <a:srgbClr val="2FD6BF"/>
+                </a:solidFill>
+                <a:latin typeface="Arial"/>
+              </a:rPr>
+              <a:t>WHY IT'S DIFFERENT</a:t>
+            </a:r>
+          </a:p>
+        </p:txBody>
+      </p:sp>
+      <p:sp>
+        <p:nvSpPr>
+          <p:cNvPr id="3" name="TextBox 2"/>
+          <p:cNvSpPr txBox="1"/>
+          <p:nvPr/>
+        </p:nvSpPr>
+        <p:spPr>
+          <a:xfrm>
+            <a:off x="822960" y="2011680"/>
+            <a:ext cx="10515600" cy="2926080"/>
+          </a:xfrm>
+          <a:prstGeom prst="rect">
+            <a:avLst/>
+          </a:prstGeom>
+          <a:noFill/>
+        </p:spPr>
+        <p:txBody>
+          <a:bodyPr wrap="square">
+            <a:spAutoFit/>
+          </a:bodyPr>
+          <a:lstStyle/>
+          <a:p>
+            <a:r>
+              <a:rPr sz="4600" b="1">
+                <a:solidFill>
+                  <a:srgbClr val="FFFFFF"/>
+                </a:solidFill>
+                <a:latin typeface="Arial"/>
+              </a:rPr>
+              <a:t>Same data. </a:t>
+            </a:r>
+            <a:r>
+              <a:rPr sz="4600" b="1">
+                <a:solidFill>
+                  <a:srgbClr val="F4B062"/>
+                </a:solidFill>
+                <a:latin typeface="Arial"/>
+              </a:rPr>
+              <a:t>A sharper question.</a:t>
+            </a:r>
+          </a:p>
+        </p:txBody>
+      </p:sp>
+      <p:sp>
+        <p:nvSpPr>
+          <p:cNvPr id="4" name="TextBox 3"/>
+          <p:cNvSpPr txBox="1"/>
+          <p:nvPr/>
+        </p:nvSpPr>
+        <p:spPr>
+          <a:xfrm>
+            <a:off x="822960" y="6126480"/>
+            <a:ext cx="10515600" cy="457200"/>
+          </a:xfrm>
+          <a:prstGeom prst="rect">
+            <a:avLst/>
+          </a:prstGeom>
+          <a:noFill/>
+        </p:spPr>
+        <p:txBody>
+          <a:bodyPr wrap="none">
+            <a:spAutoFit/>
+          </a:bodyPr>
+          <a:lstStyle/>
+          <a:p>
+            <a:r>
+              <a:rPr sz="1200">
+                <a:solidFill>
+                  <a:srgbClr val="8FA39D"/>
+                </a:solidFill>
+                <a:latin typeface="Arial"/>
+              </a:rPr>
+              <a:t>Brakepoint · Built with Claude Science</a:t>
+            </a:r>
+          </a:p>
+        </p:txBody>
+      </p:sp>
     </p:spTree>
   </p:cSld>
   <p:clrMapOvr>
@@ -4250,6 +5153,14 @@
 <file path=ppt/slides/slide7.xml><?xml version="1.0" encoding="utf-8"?>
 <p:sld xmlns:a="http://schemas.openxmlformats.org/drawingml/2006/main" xmlns:p="http://schemas.openxmlformats.org/presentationml/2006/main" xmlns:r="http://schemas.openxmlformats.org/officeDocument/2006/relationships">
   <p:cSld>
+    <p:bg>
+      <p:bgPr>
+        <a:solidFill>
+          <a:srgbClr val="0A1211"/>
+        </a:solidFill>
+        <a:effectLst/>
+      </p:bgPr>
+    </p:bg>
     <p:spTree>
       <p:nvGrpSpPr>
         <p:cNvPr id="1" name=""/>
@@ -4257,30 +5168,126 @@
         <p:nvPr/>
       </p:nvGrpSpPr>
       <p:grpSpPr/>
-      <p:pic>
-        <p:nvPicPr>
-          <p:cNvPr id="2" name="Picture 1" descr="s_6.png"/>
-          <p:cNvPicPr>
-            <a:picLocks noChangeAspect="1"/>
-          </p:cNvPicPr>
+      <p:sp>
+        <p:nvSpPr>
+          <p:cNvPr id="2" name="TextBox 1"/>
+          <p:cNvSpPr txBox="1"/>
           <p:nvPr/>
-        </p:nvPicPr>
-        <p:blipFill>
-          <a:blip r:embed="rId2"/>
-          <a:stretch>
-            <a:fillRect/>
-          </a:stretch>
-        </p:blipFill>
+        </p:nvSpPr>
         <p:spPr>
           <a:xfrm>
-            <a:off x="0" y="0"/>
-            <a:ext cx="12191695" cy="6858000"/>
+            <a:off x="822960" y="914400"/>
+            <a:ext cx="10515600" cy="457200"/>
           </a:xfrm>
           <a:prstGeom prst="rect">
             <a:avLst/>
           </a:prstGeom>
+          <a:noFill/>
         </p:spPr>
-      </p:pic>
+        <p:txBody>
+          <a:bodyPr wrap="none">
+            <a:spAutoFit/>
+          </a:bodyPr>
+          <a:lstStyle/>
+          <a:p>
+            <a:r>
+              <a:rPr sz="1500" b="1">
+                <a:solidFill>
+                  <a:srgbClr val="2FD6BF"/>
+                </a:solidFill>
+                <a:latin typeface="Arial"/>
+              </a:rPr>
+              <a:t>THE SHORTLIST</a:t>
+            </a:r>
+          </a:p>
+        </p:txBody>
+      </p:sp>
+      <p:sp>
+        <p:nvSpPr>
+          <p:cNvPr id="3" name="TextBox 2"/>
+          <p:cNvSpPr txBox="1"/>
+          <p:nvPr/>
+        </p:nvSpPr>
+        <p:spPr>
+          <a:xfrm>
+            <a:off x="822960" y="2011680"/>
+            <a:ext cx="10515600" cy="2926080"/>
+          </a:xfrm>
+          <a:prstGeom prst="rect">
+            <a:avLst/>
+          </a:prstGeom>
+          <a:noFill/>
+        </p:spPr>
+        <p:txBody>
+          <a:bodyPr wrap="square">
+            <a:spAutoFit/>
+          </a:bodyPr>
+          <a:lstStyle/>
+          <a:p>
+            <a:r>
+              <a:rPr sz="4600" b="1">
+                <a:solidFill>
+                  <a:srgbClr val="FFFFFF"/>
+                </a:solidFill>
+                <a:latin typeface="Arial"/>
+              </a:rPr>
+              <a:t>Five candidate brakes: </a:t>
+            </a:r>
+            <a:r>
+              <a:rPr sz="4600" b="1">
+                <a:solidFill>
+                  <a:srgbClr val="F4B062"/>
+                </a:solidFill>
+                <a:latin typeface="Arial"/>
+              </a:rPr>
+              <a:t>CBLB, CD5, DGKA, SMAD3, UBASH3A</a:t>
+            </a:r>
+            <a:r>
+              <a:rPr sz="4600" b="1">
+                <a:solidFill>
+                  <a:srgbClr val="FFFFFF"/>
+                </a:solidFill>
+                <a:latin typeface="Arial"/>
+              </a:rPr>
+              <a:t>.</a:t>
+            </a:r>
+          </a:p>
+        </p:txBody>
+      </p:sp>
+      <p:sp>
+        <p:nvSpPr>
+          <p:cNvPr id="4" name="TextBox 3"/>
+          <p:cNvSpPr txBox="1"/>
+          <p:nvPr/>
+        </p:nvSpPr>
+        <p:spPr>
+          <a:xfrm>
+            <a:off x="822960" y="6126480"/>
+            <a:ext cx="10515600" cy="457200"/>
+          </a:xfrm>
+          <a:prstGeom prst="rect">
+            <a:avLst/>
+          </a:prstGeom>
+          <a:noFill/>
+        </p:spPr>
+        <p:txBody>
+          <a:bodyPr wrap="none">
+            <a:spAutoFit/>
+          </a:bodyPr>
+          <a:lstStyle/>
+          <a:p>
+            <a:r>
+              <a:rPr sz="1200">
+                <a:solidFill>
+                  <a:srgbClr val="8FA39D"/>
+                </a:solidFill>
+                <a:latin typeface="Arial"/>
+              </a:rPr>
+              <a:t>Brakepoint · Built with Claude Science</a:t>
+            </a:r>
+          </a:p>
+        </p:txBody>
+      </p:sp>
     </p:spTree>
   </p:cSld>
   <p:clrMapOvr>
@@ -4292,6 +5299,14 @@
 <file path=ppt/slides/slide8.xml><?xml version="1.0" encoding="utf-8"?>
 <p:sld xmlns:a="http://schemas.openxmlformats.org/drawingml/2006/main" xmlns:p="http://schemas.openxmlformats.org/presentationml/2006/main" xmlns:r="http://schemas.openxmlformats.org/officeDocument/2006/relationships">
   <p:cSld>
+    <p:bg>
+      <p:bgPr>
+        <a:solidFill>
+          <a:srgbClr val="0A1211"/>
+        </a:solidFill>
+        <a:effectLst/>
+      </p:bgPr>
+    </p:bg>
     <p:spTree>
       <p:nvGrpSpPr>
         <p:cNvPr id="1" name=""/>
@@ -4299,30 +5314,263 @@
         <p:nvPr/>
       </p:nvGrpSpPr>
       <p:grpSpPr/>
-      <p:pic>
-        <p:nvPicPr>
-          <p:cNvPr id="2" name="Picture 1" descr="s_7.png"/>
-          <p:cNvPicPr>
-            <a:picLocks noChangeAspect="1"/>
-          </p:cNvPicPr>
+      <p:sp>
+        <p:nvSpPr>
+          <p:cNvPr id="2" name="TextBox 1"/>
+          <p:cNvSpPr txBox="1"/>
           <p:nvPr/>
-        </p:nvPicPr>
-        <p:blipFill>
-          <a:blip r:embed="rId2"/>
-          <a:stretch>
-            <a:fillRect/>
-          </a:stretch>
-        </p:blipFill>
+        </p:nvSpPr>
         <p:spPr>
           <a:xfrm>
-            <a:off x="0" y="0"/>
-            <a:ext cx="12191695" cy="6858000"/>
+            <a:off x="822960" y="914400"/>
+            <a:ext cx="10515600" cy="457200"/>
           </a:xfrm>
           <a:prstGeom prst="rect">
             <a:avLst/>
           </a:prstGeom>
+          <a:noFill/>
         </p:spPr>
-      </p:pic>
+        <p:txBody>
+          <a:bodyPr wrap="none">
+            <a:spAutoFit/>
+          </a:bodyPr>
+          <a:lstStyle/>
+          <a:p>
+            <a:r>
+              <a:rPr sz="1500" b="1">
+                <a:solidFill>
+                  <a:srgbClr val="2FD6BF"/>
+                </a:solidFill>
+                <a:latin typeface="Arial"/>
+              </a:rPr>
+              <a:t>THE LEAD · CBLB</a:t>
+            </a:r>
+          </a:p>
+        </p:txBody>
+      </p:sp>
+      <p:sp>
+        <p:nvSpPr>
+          <p:cNvPr id="3" name="TextBox 2"/>
+          <p:cNvSpPr txBox="1"/>
+          <p:nvPr/>
+        </p:nvSpPr>
+        <p:spPr>
+          <a:xfrm>
+            <a:off x="822960" y="2011680"/>
+            <a:ext cx="10515600" cy="2926080"/>
+          </a:xfrm>
+          <a:prstGeom prst="rect">
+            <a:avLst/>
+          </a:prstGeom>
+          <a:noFill/>
+        </p:spPr>
+        <p:txBody>
+          <a:bodyPr wrap="square">
+            <a:spAutoFit/>
+          </a:bodyPr>
+          <a:lstStyle/>
+          <a:p>
+            <a:r>
+              <a:rPr sz="4600" b="1">
+                <a:solidFill>
+                  <a:srgbClr val="F4B062"/>
+                </a:solidFill>
+                <a:latin typeface="Arial"/>
+              </a:rPr>
+              <a:t>CBLB</a:t>
+            </a:r>
+            <a:r>
+              <a:rPr sz="4600" b="1">
+                <a:solidFill>
+                  <a:srgbClr val="FFFFFF"/>
+                </a:solidFill>
+                <a:latin typeface="Arial"/>
+              </a:rPr>
+              <a:t> — inhibitors already in early-phase trials.</a:t>
+            </a:r>
+          </a:p>
+        </p:txBody>
+      </p:sp>
+      <p:sp>
+        <p:nvSpPr>
+          <p:cNvPr id="4" name="TextBox 3"/>
+          <p:cNvSpPr txBox="1"/>
+          <p:nvPr/>
+        </p:nvSpPr>
+        <p:spPr>
+          <a:xfrm>
+            <a:off x="822960" y="6126480"/>
+            <a:ext cx="10515600" cy="457200"/>
+          </a:xfrm>
+          <a:prstGeom prst="rect">
+            <a:avLst/>
+          </a:prstGeom>
+          <a:noFill/>
+        </p:spPr>
+        <p:txBody>
+          <a:bodyPr wrap="none">
+            <a:spAutoFit/>
+          </a:bodyPr>
+          <a:lstStyle/>
+          <a:p>
+            <a:r>
+              <a:rPr sz="1200">
+                <a:solidFill>
+                  <a:srgbClr val="8FA39D"/>
+                </a:solidFill>
+                <a:latin typeface="Arial"/>
+              </a:rPr>
+              <a:t>Brakepoint · Built with Claude Science</a:t>
+            </a:r>
+          </a:p>
+        </p:txBody>
+      </p:sp>
+    </p:spTree>
+  </p:cSld>
+  <p:clrMapOvr>
+    <a:masterClrMapping/>
+  </p:clrMapOvr>
+</p:sld>
+</file>
+
+<file path=ppt/slides/slide9.xml><?xml version="1.0" encoding="utf-8"?>
+<p:sld xmlns:a="http://schemas.openxmlformats.org/drawingml/2006/main" xmlns:p="http://schemas.openxmlformats.org/presentationml/2006/main" xmlns:r="http://schemas.openxmlformats.org/officeDocument/2006/relationships">
+  <p:cSld>
+    <p:bg>
+      <p:bgPr>
+        <a:solidFill>
+          <a:srgbClr val="0A1211"/>
+        </a:solidFill>
+        <a:effectLst/>
+      </p:bgPr>
+    </p:bg>
+    <p:spTree>
+      <p:nvGrpSpPr>
+        <p:cNvPr id="1" name=""/>
+        <p:cNvGrpSpPr/>
+        <p:nvPr/>
+      </p:nvGrpSpPr>
+      <p:grpSpPr/>
+      <p:sp>
+        <p:nvSpPr>
+          <p:cNvPr id="2" name="TextBox 1"/>
+          <p:cNvSpPr txBox="1"/>
+          <p:nvPr/>
+        </p:nvSpPr>
+        <p:spPr>
+          <a:xfrm>
+            <a:off x="822960" y="914400"/>
+            <a:ext cx="10515600" cy="457200"/>
+          </a:xfrm>
+          <a:prstGeom prst="rect">
+            <a:avLst/>
+          </a:prstGeom>
+          <a:noFill/>
+        </p:spPr>
+        <p:txBody>
+          <a:bodyPr wrap="none">
+            <a:spAutoFit/>
+          </a:bodyPr>
+          <a:lstStyle/>
+          <a:p>
+            <a:r>
+              <a:rPr sz="1500" b="1">
+                <a:solidFill>
+                  <a:srgbClr val="2FD6BF"/>
+                </a:solidFill>
+                <a:latin typeface="Arial"/>
+              </a:rPr>
+              <a:t>REPORTED HONESTLY</a:t>
+            </a:r>
+          </a:p>
+        </p:txBody>
+      </p:sp>
+      <p:sp>
+        <p:nvSpPr>
+          <p:cNvPr id="3" name="TextBox 2"/>
+          <p:cNvSpPr txBox="1"/>
+          <p:nvPr/>
+        </p:nvSpPr>
+        <p:spPr>
+          <a:xfrm>
+            <a:off x="822960" y="2011680"/>
+            <a:ext cx="10515600" cy="2926080"/>
+          </a:xfrm>
+          <a:prstGeom prst="rect">
+            <a:avLst/>
+          </a:prstGeom>
+          <a:noFill/>
+        </p:spPr>
+        <p:txBody>
+          <a:bodyPr wrap="square">
+            <a:spAutoFit/>
+          </a:bodyPr>
+          <a:lstStyle/>
+          <a:p>
+            <a:r>
+              <a:rPr sz="4600" b="1">
+                <a:solidFill>
+                  <a:srgbClr val="FFFFFF"/>
+                </a:solidFill>
+                <a:latin typeface="Arial"/>
+              </a:rPr>
+              <a:t>CD5 &amp; DGKA hold up; the rest are </a:t>
+            </a:r>
+            <a:r>
+              <a:rPr sz="4600" b="1">
+                <a:solidFill>
+                  <a:srgbClr val="F4B062"/>
+                </a:solidFill>
+                <a:latin typeface="Arial"/>
+              </a:rPr>
+              <a:t>donor-split</a:t>
+            </a:r>
+            <a:r>
+              <a:rPr sz="4600" b="1">
+                <a:solidFill>
+                  <a:srgbClr val="FFFFFF"/>
+                </a:solidFill>
+                <a:latin typeface="Arial"/>
+              </a:rPr>
+              <a:t> (p = 0.70).</a:t>
+            </a:r>
+          </a:p>
+        </p:txBody>
+      </p:sp>
+      <p:sp>
+        <p:nvSpPr>
+          <p:cNvPr id="4" name="TextBox 3"/>
+          <p:cNvSpPr txBox="1"/>
+          <p:nvPr/>
+        </p:nvSpPr>
+        <p:spPr>
+          <a:xfrm>
+            <a:off x="822960" y="6126480"/>
+            <a:ext cx="10515600" cy="457200"/>
+          </a:xfrm>
+          <a:prstGeom prst="rect">
+            <a:avLst/>
+          </a:prstGeom>
+          <a:noFill/>
+        </p:spPr>
+        <p:txBody>
+          <a:bodyPr wrap="none">
+            <a:spAutoFit/>
+          </a:bodyPr>
+          <a:lstStyle/>
+          <a:p>
+            <a:r>
+              <a:rPr sz="1200">
+                <a:solidFill>
+                  <a:srgbClr val="8FA39D"/>
+                </a:solidFill>
+                <a:latin typeface="Arial"/>
+              </a:rPr>
+              <a:t>Brakepoint · Built with Claude Science</a:t>
+            </a:r>
+          </a:p>
+        </p:txBody>
+      </p:sp>
     </p:spTree>
   </p:cSld>
   <p:clrMapOvr>

</xml_diff>

<commit_message>
feat: rework demo video — live explorer scene, human-voice narration, styled captions
- Add an Explorer scene: a screen-recording of the interactive causal map
  (search/hover, CBLB lit up with its tooltip) framed in a browser mock, beside
  type/hover/axes annotations — showing the tool, not just describing it.
- Replace narration with a natural human-voice model (F5-TTS, rendered on the DGX
  Spark) at conversational pace; add a stakes hook and a result-first close with
  the lead (CBLB) and the five candidates shown on screen.
- 11-scene composition (~2:57); per-sentence, on-brand styled player captions.
- Update deck (11 slides), narration script, and submission metadata to match.
</commit_message>
<xml_diff>
--- a/deliverables/demo_deck.pptx
+++ b/deliverables/demo_deck.pptx
@@ -15,6 +15,7 @@
     <p:sldId id="263" r:id="rId15"/>
     <p:sldId id="264" r:id="rId16"/>
     <p:sldId id="265" r:id="rId17"/>
+    <p:sldId id="266" r:id="rId18"/>
   </p:sldIdLst>
   <p:sldSz cx="12191695" cy="6858000" type="screen4x3"/>
   <p:notesSz cx="6858000" cy="9144000"/>
@@ -511,7 +512,7 @@
           <a:lstStyle/>
           <a:p>
             <a:r>
-              <a:t>Checkpoint immunotherapy works by releasing the brakes on a T cell. So we went looking for those brakes — genome-wide. This is Brakepoint, built with Claude Science.</a:t>
+              <a:t>Checkpoint drugs work by releasing the brakes on a T cell — but they help only a minority of patients, because only a handful of those brakes are drugged. So we went looking for the rest, genome-wide. This is Brakepoint, built with Claude Science.</a:t>
             </a:r>
           </a:p>
         </p:txBody>
@@ -581,7 +582,77 @@
           <a:lstStyle/>
           <a:p>
             <a:r>
-              <a:t>Every number here traces back to versioned code — and to a self-check that caught a real bias in our effect-size code before it reached a figure. Open source; every figure regenerates with one command. This is Brakepoint, built with Claude Science.</a:t>
+              <a:t>And we're honest about what two donors can support. CD5 and DGKA hold up in both; the other three ride on one donor. As a group, known brakes aren't significantly enriched — so this is a ranked shortlist for the full cohort, a hypothesis to test, not a finished answer.</a:t>
+            </a:r>
+          </a:p>
+        </p:txBody>
+      </p:sp>
+      <p:sp>
+        <p:nvSpPr>
+          <p:cNvPr id="4" name="Slide Number Placeholder 3"/>
+          <p:cNvSpPr>
+            <a:spLocks noGrp="1"/>
+          </p:cNvSpPr>
+          <p:nvPr>
+            <p:ph type="sldNum" idx="5" sz="quarter"/>
+          </p:nvPr>
+        </p:nvSpPr>
+        <p:spPr/>
+      </p:sp>
+    </p:spTree>
+  </p:cSld>
+  <p:clrMapOvr>
+    <a:masterClrMapping/>
+  </p:clrMapOvr>
+</p:notes>
+</file>
+
+<file path=ppt/notesSlides/notesSlide11.xml><?xml version="1.0" encoding="utf-8"?>
+<p:notes xmlns:a="http://schemas.openxmlformats.org/drawingml/2006/main" xmlns:p="http://schemas.openxmlformats.org/presentationml/2006/main" xmlns:r="http://schemas.openxmlformats.org/officeDocument/2006/relationships">
+  <p:cSld>
+    <p:spTree>
+      <p:nvGrpSpPr>
+        <p:cNvPr id="1" name=""/>
+        <p:cNvGrpSpPr/>
+        <p:nvPr/>
+      </p:nvGrpSpPr>
+      <p:grpSpPr>
+        <a:xfrm>
+          <a:off x="0" y="0"/>
+          <a:ext cx="0" cy="0"/>
+          <a:chOff x="0" y="0"/>
+          <a:chExt cx="0" cy="0"/>
+        </a:xfrm>
+      </p:grpSpPr>
+      <p:sp>
+        <p:nvSpPr>
+          <p:cNvPr id="2" name="Slide Image Placeholder 1"/>
+          <p:cNvSpPr>
+            <a:spLocks noGrp="1"/>
+          </p:cNvSpPr>
+          <p:nvPr>
+            <p:ph type="sldImg" idx="2"/>
+          </p:nvPr>
+        </p:nvSpPr>
+        <p:spPr/>
+      </p:sp>
+      <p:sp>
+        <p:nvSpPr>
+          <p:cNvPr id="3" name="Notes Placeholder 2"/>
+          <p:cNvSpPr>
+            <a:spLocks noGrp="1"/>
+          </p:cNvSpPr>
+          <p:nvPr>
+            <p:ph type="body" idx="3" sz="quarter"/>
+          </p:nvPr>
+        </p:nvSpPr>
+        <p:spPr/>
+        <p:txBody>
+          <a:bodyPr/>
+          <a:lstStyle/>
+          <a:p>
+            <a:r>
+              <a:t>Five candidate brakes, led by CBLB — every number reproducible from one command, and checked against a real bug we caught ourselves. Explore the live map, clone the code, and help find the brakes today's drugs still miss. Built with Claude Science.</a:t>
             </a:r>
           </a:p>
         </p:txBody>
@@ -931,7 +1002,7 @@
           <a:lstStyle/>
           <a:p>
             <a:r>
-              <a:t>And that's the edge. Differential expression finds correlations — not what to drug. Genetics points to a locus, rarely a direction. We measure what a knockdown actually does, and which way it pushes — then weigh it against genetics and the clinic.</a:t>
+              <a:t>And this isn't a static picture. Every one of the eleven thousand tested knockdowns is here to explore — search any gene, hover any point, and read its causal effect and its direction. It's the real leaderboard, live.</a:t>
             </a:r>
           </a:p>
         </p:txBody>
@@ -1001,7 +1072,7 @@
           <a:lstStyle/>
           <a:p>
             <a:r>
-              <a:t>From that map, five prior-informed candidates: CBLB, CD5, DGKA, SMAD3, and UBASH3A — each scored across seven lines of evidence, from causal effect and direction to human genetics and clinical precedent.</a:t>
+              <a:t>And that's the edge. Differential expression finds correlations — not what to drug. Genetics points to a locus, rarely a direction. We measure what a knockdown actually does, and which way it pushes — then weigh it against genetics and the clinic.</a:t>
             </a:r>
           </a:p>
         </p:txBody>
@@ -1071,7 +1142,7 @@
           <a:lstStyle/>
           <a:p>
             <a:r>
-              <a:t>Our lead is CBLB. It's a natural off-switch for T-cell activation, and inhibitors are already in early-phase trials. Its genetics point the same way, and it lands in our brake quadrant. CD5 and DGKA come next — and both hold up across donors.</a:t>
+              <a:t>From that map, five prior-informed candidates: CBLB, CD5, DGKA, SMAD3, and UBASH3A — each scored across seven lines of evidence, from causal effect and direction to human genetics and clinical precedent.</a:t>
             </a:r>
           </a:p>
         </p:txBody>
@@ -1141,7 +1212,7 @@
           <a:lstStyle/>
           <a:p>
             <a:r>
-              <a:t>And we're honest about what two donors can support. CD5 and DGKA hold up in both; the other three ride on one donor. As a group, known brakes aren't significantly enriched — so this is a ranked shortlist for the full cohort, a hypothesis to test, not a finished answer.</a:t>
+              <a:t>Our lead is CBLB. It's a natural off-switch for T-cell activation, and inhibitors are already in early-phase trials. Its genetics point the same way, and it lands in our brake quadrant. CD5 and DGKA come next — and both hold up across donors.</a:t>
             </a:r>
           </a:p>
         </p:txBody>
@@ -4330,6 +4401,152 @@
                 </a:solidFill>
                 <a:latin typeface="Arial"/>
               </a:rPr>
+              <a:t>REPORTED HONESTLY</a:t>
+            </a:r>
+          </a:p>
+        </p:txBody>
+      </p:sp>
+      <p:sp>
+        <p:nvSpPr>
+          <p:cNvPr id="3" name="TextBox 2"/>
+          <p:cNvSpPr txBox="1"/>
+          <p:nvPr/>
+        </p:nvSpPr>
+        <p:spPr>
+          <a:xfrm>
+            <a:off x="822960" y="2011680"/>
+            <a:ext cx="10515600" cy="2926080"/>
+          </a:xfrm>
+          <a:prstGeom prst="rect">
+            <a:avLst/>
+          </a:prstGeom>
+          <a:noFill/>
+        </p:spPr>
+        <p:txBody>
+          <a:bodyPr wrap="square">
+            <a:spAutoFit/>
+          </a:bodyPr>
+          <a:lstStyle/>
+          <a:p>
+            <a:r>
+              <a:rPr sz="4600" b="1">
+                <a:solidFill>
+                  <a:srgbClr val="FFFFFF"/>
+                </a:solidFill>
+                <a:latin typeface="Arial"/>
+              </a:rPr>
+              <a:t>CD5 &amp; DGKA hold up; the rest are </a:t>
+            </a:r>
+            <a:r>
+              <a:rPr sz="4600" b="1">
+                <a:solidFill>
+                  <a:srgbClr val="F4B062"/>
+                </a:solidFill>
+                <a:latin typeface="Arial"/>
+              </a:rPr>
+              <a:t>donor-split</a:t>
+            </a:r>
+            <a:r>
+              <a:rPr sz="4600" b="1">
+                <a:solidFill>
+                  <a:srgbClr val="FFFFFF"/>
+                </a:solidFill>
+                <a:latin typeface="Arial"/>
+              </a:rPr>
+              <a:t> (p = 0.70).</a:t>
+            </a:r>
+          </a:p>
+        </p:txBody>
+      </p:sp>
+      <p:sp>
+        <p:nvSpPr>
+          <p:cNvPr id="4" name="TextBox 3"/>
+          <p:cNvSpPr txBox="1"/>
+          <p:nvPr/>
+        </p:nvSpPr>
+        <p:spPr>
+          <a:xfrm>
+            <a:off x="822960" y="6126480"/>
+            <a:ext cx="10515600" cy="457200"/>
+          </a:xfrm>
+          <a:prstGeom prst="rect">
+            <a:avLst/>
+          </a:prstGeom>
+          <a:noFill/>
+        </p:spPr>
+        <p:txBody>
+          <a:bodyPr wrap="none">
+            <a:spAutoFit/>
+          </a:bodyPr>
+          <a:lstStyle/>
+          <a:p>
+            <a:r>
+              <a:rPr sz="1200">
+                <a:solidFill>
+                  <a:srgbClr val="8FA39D"/>
+                </a:solidFill>
+                <a:latin typeface="Arial"/>
+              </a:rPr>
+              <a:t>Brakepoint · Built with Claude Science</a:t>
+            </a:r>
+          </a:p>
+        </p:txBody>
+      </p:sp>
+    </p:spTree>
+  </p:cSld>
+  <p:clrMapOvr>
+    <a:masterClrMapping/>
+  </p:clrMapOvr>
+</p:sld>
+</file>
+
+<file path=ppt/slides/slide11.xml><?xml version="1.0" encoding="utf-8"?>
+<p:sld xmlns:a="http://schemas.openxmlformats.org/drawingml/2006/main" xmlns:p="http://schemas.openxmlformats.org/presentationml/2006/main" xmlns:r="http://schemas.openxmlformats.org/officeDocument/2006/relationships">
+  <p:cSld>
+    <p:bg>
+      <p:bgPr>
+        <a:solidFill>
+          <a:srgbClr val="0A1211"/>
+        </a:solidFill>
+        <a:effectLst/>
+      </p:bgPr>
+    </p:bg>
+    <p:spTree>
+      <p:nvGrpSpPr>
+        <p:cNvPr id="1" name=""/>
+        <p:cNvGrpSpPr/>
+        <p:nvPr/>
+      </p:nvGrpSpPr>
+      <p:grpSpPr/>
+      <p:sp>
+        <p:nvSpPr>
+          <p:cNvPr id="2" name="TextBox 1"/>
+          <p:cNvSpPr txBox="1"/>
+          <p:nvPr/>
+        </p:nvSpPr>
+        <p:spPr>
+          <a:xfrm>
+            <a:off x="822960" y="914400"/>
+            <a:ext cx="10515600" cy="457200"/>
+          </a:xfrm>
+          <a:prstGeom prst="rect">
+            <a:avLst/>
+          </a:prstGeom>
+          <a:noFill/>
+        </p:spPr>
+        <p:txBody>
+          <a:bodyPr wrap="none">
+            <a:spAutoFit/>
+          </a:bodyPr>
+          <a:lstStyle/>
+          <a:p>
+            <a:r>
+              <a:rPr sz="1500" b="1">
+                <a:solidFill>
+                  <a:srgbClr val="2FD6BF"/>
+                </a:solidFill>
+                <a:latin typeface="Arial"/>
+              </a:rPr>
               <a:t>OPEN SOURCE · MIT</a:t>
             </a:r>
           </a:p>
@@ -5060,7 +5277,7 @@
                 </a:solidFill>
                 <a:latin typeface="Arial"/>
               </a:rPr>
-              <a:t>WHY IT'S DIFFERENT</a:t>
+              <a:t>EXPLORE · THE LIVE LEADERBOARD</a:t>
             </a:r>
           </a:p>
         </p:txBody>
@@ -5094,7 +5311,7 @@
                 </a:solidFill>
                 <a:latin typeface="Arial"/>
               </a:rPr>
-              <a:t>Same data. </a:t>
+              <a:t>Not a picture — </a:t>
             </a:r>
             <a:r>
               <a:rPr sz="4600" b="1">
@@ -5103,7 +5320,16 @@
                 </a:solidFill>
                 <a:latin typeface="Arial"/>
               </a:rPr>
-              <a:t>A sharper question.</a:t>
+              <a:t>the real leaderboard</a:t>
+            </a:r>
+            <a:r>
+              <a:rPr sz="4600" b="1">
+                <a:solidFill>
+                  <a:srgbClr val="FFFFFF"/>
+                </a:solidFill>
+                <a:latin typeface="Arial"/>
+              </a:rPr>
+              <a:t>.</a:t>
             </a:r>
           </a:p>
         </p:txBody>
@@ -5197,7 +5423,7 @@
                 </a:solidFill>
                 <a:latin typeface="Arial"/>
               </a:rPr>
-              <a:t>THE SHORTLIST</a:t>
+              <a:t>WHY IT'S DIFFERENT</a:t>
             </a:r>
           </a:p>
         </p:txBody>
@@ -5231,7 +5457,7 @@
                 </a:solidFill>
                 <a:latin typeface="Arial"/>
               </a:rPr>
-              <a:t>Five candidate brakes: </a:t>
+              <a:t>Same data. </a:t>
             </a:r>
             <a:r>
               <a:rPr sz="4600" b="1">
@@ -5240,16 +5466,7 @@
                 </a:solidFill>
                 <a:latin typeface="Arial"/>
               </a:rPr>
-              <a:t>CBLB, CD5, DGKA, SMAD3, UBASH3A</a:t>
-            </a:r>
-            <a:r>
-              <a:rPr sz="4600" b="1">
-                <a:solidFill>
-                  <a:srgbClr val="FFFFFF"/>
-                </a:solidFill>
-                <a:latin typeface="Arial"/>
-              </a:rPr>
-              <a:t>.</a:t>
+              <a:t>A sharper question.</a:t>
             </a:r>
           </a:p>
         </p:txBody>
@@ -5343,7 +5560,7 @@
                 </a:solidFill>
                 <a:latin typeface="Arial"/>
               </a:rPr>
-              <a:t>THE LEAD · CBLB</a:t>
+              <a:t>THE SHORTLIST</a:t>
             </a:r>
           </a:p>
         </p:txBody>
@@ -5373,20 +5590,29 @@
             <a:r>
               <a:rPr sz="4600" b="1">
                 <a:solidFill>
-                  <a:srgbClr val="F4B062"/>
+                  <a:srgbClr val="FFFFFF"/>
                 </a:solidFill>
                 <a:latin typeface="Arial"/>
               </a:rPr>
-              <a:t>CBLB</a:t>
+              <a:t>Five candidate brakes: </a:t>
             </a:r>
             <a:r>
               <a:rPr sz="4600" b="1">
                 <a:solidFill>
-                  <a:srgbClr val="FFFFFF"/>
+                  <a:srgbClr val="F4B062"/>
                 </a:solidFill>
                 <a:latin typeface="Arial"/>
               </a:rPr>
-              <a:t> — inhibitors already in early-phase trials.</a:t>
+              <a:t>CBLB, CD5, DGKA, SMAD3, UBASH3A</a:t>
+            </a:r>
+            <a:r>
+              <a:rPr sz="4600" b="1">
+                <a:solidFill>
+                  <a:srgbClr val="FFFFFF"/>
+                </a:solidFill>
+                <a:latin typeface="Arial"/>
+              </a:rPr>
+              <a:t>.</a:t>
             </a:r>
           </a:p>
         </p:txBody>
@@ -5480,7 +5706,7 @@
                 </a:solidFill>
                 <a:latin typeface="Arial"/>
               </a:rPr>
-              <a:t>REPORTED HONESTLY</a:t>
+              <a:t>THE LEAD · CBLB</a:t>
             </a:r>
           </a:p>
         </p:txBody>
@@ -5510,29 +5736,20 @@
             <a:r>
               <a:rPr sz="4600" b="1">
                 <a:solidFill>
-                  <a:srgbClr val="FFFFFF"/>
+                  <a:srgbClr val="F4B062"/>
                 </a:solidFill>
                 <a:latin typeface="Arial"/>
               </a:rPr>
-              <a:t>CD5 &amp; DGKA hold up; the rest are </a:t>
+              <a:t>CBLB</a:t>
             </a:r>
             <a:r>
               <a:rPr sz="4600" b="1">
                 <a:solidFill>
-                  <a:srgbClr val="F4B062"/>
+                  <a:srgbClr val="FFFFFF"/>
                 </a:solidFill>
                 <a:latin typeface="Arial"/>
               </a:rPr>
-              <a:t>donor-split</a:t>
-            </a:r>
-            <a:r>
-              <a:rPr sz="4600" b="1">
-                <a:solidFill>
-                  <a:srgbClr val="FFFFFF"/>
-                </a:solidFill>
-                <a:latin typeface="Arial"/>
-              </a:rPr>
-              <a:t> (p = 0.70).</a:t>
+              <a:t> — inhibitors already in early-phase trials.</a:t>
             </a:r>
           </a:p>
         </p:txBody>

</xml_diff>